<commit_message>
Correct LLM provider documentation, improve README readability, add CI badge, refresh overview deck
</commit_message>
<xml_diff>
--- a/docs/Construction_AI_Platform_Overview.pptx
+++ b/docs/Construction_AI_Platform_Overview.pptx
@@ -2386,8 +2386,8 @@
         </p:nvSpPr>
         <p:spPr>
           <a:xfrm>
-            <a:off x="548640" y="1463040"/>
-            <a:ext cx="11094415" cy="1234440"/>
+            <a:off x="548640" y="1371600"/>
+            <a:ext cx="4206240" cy="1600200"/>
           </a:xfrm>
           <a:prstGeom prst="rect">
             <a:avLst/>
@@ -2401,12 +2401,12 @@
           <a:p>
             <a:pPr indent="0" marL="0">
               <a:lnSpc>
-                <a:spcPct val="135000"/>
+                <a:spcPct val="132000"/>
               </a:lnSpc>
               <a:buNone/>
             </a:pPr>
             <a:r>
-              <a:rPr lang="en-US" sz="1500" dirty="0">
+              <a:rPr lang="en-US" sz="1400" dirty="0">
                 <a:solidFill>
                   <a:srgbClr val="5B6B79"/>
                 </a:solidFill>
@@ -2414,9 +2414,9 @@
                 <a:ea typeface="Calibri" pitchFamily="34" charset="-122"/>
                 <a:cs typeface="Calibri" pitchFamily="34" charset="-120"/>
               </a:rPr>
-              <a:t>Every figure a decision depends on — a supplier's on-time rate, portfolio KPIs, an overdue count — is computed in code from the database. The language model is used only for what it is actually good at: reading unstructured text and writing prose. It is never asked to restate a number on its own.</a:t>
-            </a:r>
-            <a:endParaRPr lang="en-US" sz="1500" dirty="0"/>
+              <a:t>Every figure a decision depends on is computed in code from the database — never restated by the model. The language model is used only for what it is actually good at: reading unstructured text and writing prose.</a:t>
+            </a:r>
+            <a:endParaRPr lang="en-US" sz="1400" dirty="0"/>
           </a:p>
         </p:txBody>
       </p:sp>
@@ -2429,29 +2429,7 @@
         <p:spPr>
           <a:xfrm>
             <a:off x="548640" y="3063240"/>
-            <a:ext cx="5349240" cy="2880360"/>
-          </a:xfrm>
-          <a:prstGeom prst="roundRect">
-            <a:avLst>
-              <a:gd name="adj" fmla="val 3810"/>
-            </a:avLst>
-          </a:prstGeom>
-          <a:solidFill>
-            <a:srgbClr val="132A46"/>
-          </a:solidFill>
-          <a:ln/>
-        </p:spPr>
-      </p:sp>
-      <p:sp>
-        <p:nvSpPr>
-          <p:cNvPr id="5" name="Shape 3"/>
-          <p:cNvSpPr/>
-          <p:nvPr/>
-        </p:nvSpPr>
-        <p:spPr>
-          <a:xfrm>
-            <a:off x="868680" y="3383280"/>
-            <a:ext cx="594360" cy="594360"/>
+            <a:ext cx="502920" cy="502920"/>
           </a:xfrm>
           <a:prstGeom prst="ellipse">
             <a:avLst/>
@@ -2464,7 +2442,7 @@
       </p:sp>
       <p:pic>
         <p:nvPicPr>
-          <p:cNvPr id="6" name="Image 0" descr="preencoded.png">    </p:cNvPr>
+          <p:cNvPr id="5" name="Image 0" descr="preencoded.png">    </p:cNvPr>
           <p:cNvPicPr>
             <a:picLocks noChangeAspect="1"/>
           </p:cNvPicPr>
@@ -2478,8 +2456,8 @@
         </p:blipFill>
         <p:spPr>
           <a:xfrm>
-            <a:off x="1002411" y="3517011"/>
-            <a:ext cx="326898" cy="326898"/>
+            <a:off x="661797" y="3176397"/>
+            <a:ext cx="276606" cy="276606"/>
           </a:xfrm>
           <a:prstGeom prst="rect">
             <a:avLst/>
@@ -2488,53 +2466,53 @@
       </p:pic>
       <p:sp>
         <p:nvSpPr>
+          <p:cNvPr id="6" name="Text 3"/>
+          <p:cNvSpPr/>
+          <p:nvPr/>
+        </p:nvSpPr>
+        <p:spPr>
+          <a:xfrm>
+            <a:off x="1207008" y="3035808"/>
+            <a:ext cx="3566160" cy="365760"/>
+          </a:xfrm>
+          <a:prstGeom prst="rect">
+            <a:avLst/>
+          </a:prstGeom>
+          <a:noFill/>
+          <a:ln/>
+        </p:spPr>
+        <p:txBody>
+          <a:bodyPr wrap="square" lIns="0" tIns="0" rIns="0" bIns="0" rtlCol="0" anchor="ctr"/>
+          <a:lstStyle/>
+          <a:p>
+            <a:pPr indent="0" marL="0">
+              <a:buNone/>
+            </a:pPr>
+            <a:r>
+              <a:rPr lang="en-US" sz="1400" b="1" dirty="0">
+                <a:solidFill>
+                  <a:srgbClr val="132A46"/>
+                </a:solidFill>
+                <a:latin typeface="Calibri" pitchFamily="34" charset="0"/>
+                <a:ea typeface="Calibri" pitchFamily="34" charset="-122"/>
+                <a:cs typeface="Calibri" pitchFamily="34" charset="-120"/>
+              </a:rPr>
+              <a:t>Computed in code</a:t>
+            </a:r>
+            <a:endParaRPr lang="en-US" sz="1400" dirty="0"/>
+          </a:p>
+        </p:txBody>
+      </p:sp>
+      <p:sp>
+        <p:nvSpPr>
           <p:cNvPr id="7" name="Text 4"/>
           <p:cNvSpPr/>
           <p:nvPr/>
         </p:nvSpPr>
         <p:spPr>
           <a:xfrm>
-            <a:off x="1600200" y="3429000"/>
-            <a:ext cx="4069080" cy="457200"/>
-          </a:xfrm>
-          <a:prstGeom prst="rect">
-            <a:avLst/>
-          </a:prstGeom>
-          <a:noFill/>
-          <a:ln/>
-        </p:spPr>
-        <p:txBody>
-          <a:bodyPr wrap="square" lIns="0" tIns="0" rIns="0" bIns="0" rtlCol="0" anchor="ctr"/>
-          <a:lstStyle/>
-          <a:p>
-            <a:pPr indent="0" marL="0">
-              <a:buNone/>
-            </a:pPr>
-            <a:r>
-              <a:rPr lang="en-US" sz="1600" b="1" dirty="0">
-                <a:solidFill>
-                  <a:srgbClr val="FFFFFF"/>
-                </a:solidFill>
-                <a:latin typeface="Calibri" pitchFamily="34" charset="0"/>
-                <a:ea typeface="Calibri" pitchFamily="34" charset="-122"/>
-                <a:cs typeface="Calibri" pitchFamily="34" charset="-120"/>
-              </a:rPr>
-              <a:t>Computed in code</a:t>
-            </a:r>
-            <a:endParaRPr lang="en-US" sz="1600" dirty="0"/>
-          </a:p>
-        </p:txBody>
-      </p:sp>
-      <p:sp>
-        <p:nvSpPr>
-          <p:cNvPr id="8" name="Text 5"/>
-          <p:cNvSpPr/>
-          <p:nvPr/>
-        </p:nvSpPr>
-        <p:spPr>
-          <a:xfrm>
-            <a:off x="868680" y="4114800"/>
-            <a:ext cx="4709160" cy="1645920"/>
+            <a:off x="1207008" y="3410712"/>
+            <a:ext cx="3566160" cy="1051560"/>
           </a:xfrm>
           <a:prstGeom prst="rect">
             <a:avLst/>
@@ -2548,57 +2526,35 @@
           <a:p>
             <a:pPr indent="0" marL="0">
               <a:lnSpc>
-                <a:spcPct val="130000"/>
+                <a:spcPct val="125000"/>
               </a:lnSpc>
               <a:buNone/>
             </a:pPr>
             <a:r>
-              <a:rPr lang="en-US" sz="1300" dirty="0">
-                <a:solidFill>
-                  <a:srgbClr val="C7D2DE"/>
-                </a:solidFill>
-                <a:latin typeface="Calibri" pitchFamily="34" charset="0"/>
-                <a:ea typeface="Calibri" pitchFamily="34" charset="-122"/>
-                <a:cs typeface="Calibri" pitchFamily="34" charset="-120"/>
-              </a:rPr>
-              <a:t>On-time rates, KPI totals, overdue counts, risk scores — arithmetic run directly against the database, byte-exact against the source of truth.</a:t>
-            </a:r>
-            <a:endParaRPr lang="en-US" sz="1300" dirty="0"/>
-          </a:p>
-        </p:txBody>
-      </p:sp>
-      <p:sp>
-        <p:nvSpPr>
-          <p:cNvPr id="9" name="Shape 6"/>
-          <p:cNvSpPr/>
-          <p:nvPr/>
-        </p:nvSpPr>
-        <p:spPr>
-          <a:xfrm>
-            <a:off x="6217920" y="3063240"/>
-            <a:ext cx="5349240" cy="2880360"/>
-          </a:xfrm>
-          <a:prstGeom prst="roundRect">
-            <a:avLst>
-              <a:gd name="adj" fmla="val 3810"/>
-            </a:avLst>
-          </a:prstGeom>
-          <a:solidFill>
-            <a:srgbClr val="F4F6F8"/>
-          </a:solidFill>
-          <a:ln/>
-        </p:spPr>
-      </p:sp>
-      <p:sp>
-        <p:nvSpPr>
-          <p:cNvPr id="10" name="Shape 7"/>
-          <p:cNvSpPr/>
-          <p:nvPr/>
-        </p:nvSpPr>
-        <p:spPr>
-          <a:xfrm>
-            <a:off x="6537960" y="3383280"/>
-            <a:ext cx="594360" cy="594360"/>
+              <a:rPr lang="en-US" sz="1200" dirty="0">
+                <a:solidFill>
+                  <a:srgbClr val="5B6B79"/>
+                </a:solidFill>
+                <a:latin typeface="Calibri" pitchFamily="34" charset="0"/>
+                <a:ea typeface="Calibri" pitchFamily="34" charset="-122"/>
+                <a:cs typeface="Calibri" pitchFamily="34" charset="-120"/>
+              </a:rPr>
+              <a:t>KPI tiles: on-time rates, overdue counts, totals — byte-exact against the database.</a:t>
+            </a:r>
+            <a:endParaRPr lang="en-US" sz="1200" dirty="0"/>
+          </a:p>
+        </p:txBody>
+      </p:sp>
+      <p:sp>
+        <p:nvSpPr>
+          <p:cNvPr id="8" name="Shape 5"/>
+          <p:cNvSpPr/>
+          <p:nvPr/>
+        </p:nvSpPr>
+        <p:spPr>
+          <a:xfrm>
+            <a:off x="548640" y="4572000"/>
+            <a:ext cx="502920" cy="502920"/>
           </a:xfrm>
           <a:prstGeom prst="ellipse">
             <a:avLst/>
@@ -2611,7 +2567,7 @@
       </p:sp>
       <p:pic>
         <p:nvPicPr>
-          <p:cNvPr id="11" name="Image 1" descr="preencoded.png">    </p:cNvPr>
+          <p:cNvPr id="9" name="Image 1" descr="preencoded.png">    </p:cNvPr>
           <p:cNvPicPr>
             <a:picLocks noChangeAspect="1"/>
           </p:cNvPicPr>
@@ -2625,8 +2581,8 @@
         </p:blipFill>
         <p:spPr>
           <a:xfrm>
-            <a:off x="6671691" y="3517011"/>
-            <a:ext cx="326898" cy="326898"/>
+            <a:off x="661797" y="4685157"/>
+            <a:ext cx="276606" cy="276606"/>
           </a:xfrm>
           <a:prstGeom prst="rect">
             <a:avLst/>
@@ -2635,14 +2591,14 @@
       </p:pic>
       <p:sp>
         <p:nvSpPr>
-          <p:cNvPr id="12" name="Text 8"/>
-          <p:cNvSpPr/>
-          <p:nvPr/>
-        </p:nvSpPr>
-        <p:spPr>
-          <a:xfrm>
-            <a:off x="7269480" y="3429000"/>
-            <a:ext cx="4069080" cy="457200"/>
+          <p:cNvPr id="10" name="Text 6"/>
+          <p:cNvSpPr/>
+          <p:nvPr/>
+        </p:nvSpPr>
+        <p:spPr>
+          <a:xfrm>
+            <a:off x="1207008" y="4544568"/>
+            <a:ext cx="3566160" cy="365760"/>
           </a:xfrm>
           <a:prstGeom prst="rect">
             <a:avLst/>
@@ -2658,7 +2614,7 @@
               <a:buNone/>
             </a:pPr>
             <a:r>
-              <a:rPr lang="en-US" sz="1600" b="1" dirty="0">
+              <a:rPr lang="en-US" sz="1400" b="1" dirty="0">
                 <a:solidFill>
                   <a:srgbClr val="132A46"/>
                 </a:solidFill>
@@ -2668,20 +2624,20 @@
               </a:rPr>
               <a:t>Generated by the model</a:t>
             </a:r>
-            <a:endParaRPr lang="en-US" sz="1600" dirty="0"/>
-          </a:p>
-        </p:txBody>
-      </p:sp>
-      <p:sp>
-        <p:nvSpPr>
-          <p:cNvPr id="13" name="Text 9"/>
-          <p:cNvSpPr/>
-          <p:nvPr/>
-        </p:nvSpPr>
-        <p:spPr>
-          <a:xfrm>
-            <a:off x="6537960" y="4114800"/>
-            <a:ext cx="4709160" cy="1645920"/>
+            <a:endParaRPr lang="en-US" sz="1400" dirty="0"/>
+          </a:p>
+        </p:txBody>
+      </p:sp>
+      <p:sp>
+        <p:nvSpPr>
+          <p:cNvPr id="11" name="Text 7"/>
+          <p:cNvSpPr/>
+          <p:nvPr/>
+        </p:nvSpPr>
+        <p:spPr>
+          <a:xfrm>
+            <a:off x="1207008" y="4919472"/>
+            <a:ext cx="3566160" cy="1051560"/>
           </a:xfrm>
           <a:prstGeom prst="rect">
             <a:avLst/>
@@ -2695,12 +2651,12 @@
           <a:p>
             <a:pPr indent="0" marL="0">
               <a:lnSpc>
-                <a:spcPct val="130000"/>
+                <a:spcPct val="125000"/>
               </a:lnSpc>
               <a:buNone/>
             </a:pPr>
             <a:r>
-              <a:rPr lang="en-US" sz="1300" dirty="0">
+              <a:rPr lang="en-US" sz="1200" dirty="0">
                 <a:solidFill>
                   <a:srgbClr val="5B6B79"/>
                 </a:solidFill>
@@ -2708,15 +2664,112 @@
                 <a:ea typeface="Calibri" pitchFamily="34" charset="-122"/>
                 <a:cs typeface="Calibri" pitchFamily="34" charset="-120"/>
               </a:rPr>
-              <a:t>Reading free text, judging severity, and writing the narrative — the parts language understanding is actually suited for.</a:t>
-            </a:r>
-            <a:endParaRPr lang="en-US" sz="1300" dirty="0"/>
-          </a:p>
-        </p:txBody>
-      </p:sp>
-      <p:sp>
-        <p:nvSpPr>
-          <p:cNvPr id="14" name="Text 10"/>
+              <a:t>The narrative below them: judgment and prose, never a number of its own.</a:t>
+            </a:r>
+            <a:endParaRPr lang="en-US" sz="1200" dirty="0"/>
+          </a:p>
+        </p:txBody>
+      </p:sp>
+      <p:sp>
+        <p:nvSpPr>
+          <p:cNvPr id="12" name="Shape 8"/>
+          <p:cNvSpPr/>
+          <p:nvPr/>
+        </p:nvSpPr>
+        <p:spPr>
+          <a:xfrm>
+            <a:off x="5074920" y="1982879"/>
+            <a:ext cx="6611112" cy="3486603"/>
+          </a:xfrm>
+          <a:prstGeom prst="roundRect">
+            <a:avLst>
+              <a:gd name="adj" fmla="val 2098"/>
+            </a:avLst>
+          </a:prstGeom>
+          <a:solidFill>
+            <a:srgbClr val="FFFFFF"/>
+          </a:solidFill>
+          <a:ln w="12700">
+            <a:solidFill>
+              <a:srgbClr val="E2E6EA"/>
+            </a:solidFill>
+            <a:prstDash val="solid"/>
+          </a:ln>
+          <a:effectLst>
+            <a:outerShdw sx="100000" sy="100000" kx="0" ky="0" algn="bl" rotWithShape="0" blurRad="127000" dist="38100" dir="5400000">
+              <a:srgbClr val="1F2937">
+                <a:alpha val="18000"/>
+              </a:srgbClr>
+            </a:outerShdw>
+          </a:effectLst>
+        </p:spPr>
+      </p:sp>
+      <p:pic>
+        <p:nvPicPr>
+          <p:cNvPr id="13" name="Image 2" descr="Executive weekly report with computed KPI tiles and an AI-written narrative">    </p:cNvPr>
+          <p:cNvPicPr>
+            <a:picLocks noChangeAspect="1"/>
+          </p:cNvPicPr>
+          <p:nvPr/>
+        </p:nvPicPr>
+        <p:blipFill>
+          <a:blip r:embed="rId3"/>
+          <a:stretch>
+            <a:fillRect/>
+          </a:stretch>
+        </p:blipFill>
+        <p:spPr>
+          <a:xfrm>
+            <a:off x="5120640" y="2028599"/>
+            <a:ext cx="6519672" cy="3395163"/>
+          </a:xfrm>
+          <a:prstGeom prst="rect">
+            <a:avLst/>
+          </a:prstGeom>
+        </p:spPr>
+      </p:pic>
+      <p:sp>
+        <p:nvSpPr>
+          <p:cNvPr id="14" name="Text 9"/>
+          <p:cNvSpPr/>
+          <p:nvPr/>
+        </p:nvSpPr>
+        <p:spPr>
+          <a:xfrm>
+            <a:off x="5120640" y="5515201"/>
+            <a:ext cx="6519672" cy="274320"/>
+          </a:xfrm>
+          <a:prstGeom prst="rect">
+            <a:avLst/>
+          </a:prstGeom>
+          <a:noFill/>
+          <a:ln/>
+        </p:spPr>
+        <p:txBody>
+          <a:bodyPr wrap="square" lIns="0" tIns="0" rIns="0" bIns="0" rtlCol="0" anchor="ctr"/>
+          <a:lstStyle/>
+          <a:p>
+            <a:pPr algn="ctr" indent="0" marL="0">
+              <a:buNone/>
+            </a:pPr>
+            <a:r>
+              <a:rPr lang="en-US" sz="1100" i="1" dirty="0">
+                <a:solidFill>
+                  <a:srgbClr val="8A97A3"/>
+                </a:solidFill>
+                <a:latin typeface="Calibri" pitchFamily="34" charset="0"/>
+                <a:ea typeface="Calibri" pitchFamily="34" charset="-122"/>
+                <a:cs typeface="Calibri" pitchFamily="34" charset="-120"/>
+              </a:rPr>
+              <a:t>A real executive report — computed tiles above, AI narrative below</a:t>
+            </a:r>
+            <a:endParaRPr lang="en-US" sz="1100" dirty="0"/>
+          </a:p>
+        </p:txBody>
+      </p:sp>
+      <p:sp>
+        <p:nvSpPr>
+          <p:cNvPr id="15" name="Text 10"/>
           <p:cNvSpPr/>
           <p:nvPr/>
         </p:nvSpPr>
@@ -2735,7 +2788,7 @@
           <a:bodyPr wrap="square" lIns="0" tIns="0" rIns="0" bIns="0" rtlCol="0" anchor="ctr"/>
           <a:lstStyle/>
           <a:p>
-            <a:pPr algn="l" indent="0" marL="0">
+            <a:pPr indent="0" marL="0">
               <a:buNone/>
             </a:pPr>
             <a:r>
@@ -2755,7 +2808,7 @@
       </p:sp>
       <p:sp>
         <p:nvSpPr>
-          <p:cNvPr id="15" name="Text 11"/>
+          <p:cNvPr id="16" name="Text 11"/>
           <p:cNvSpPr/>
           <p:nvPr/>
         </p:nvSpPr>
@@ -2865,57 +2918,18 @@
       </p:sp>
       <p:sp>
         <p:nvSpPr>
-          <p:cNvPr id="3" name="Text 1"/>
-          <p:cNvSpPr/>
-          <p:nvPr/>
-        </p:nvSpPr>
-        <p:spPr>
-          <a:xfrm>
-            <a:off x="548640" y="1371600"/>
-            <a:ext cx="11094415" cy="594360"/>
-          </a:xfrm>
-          <a:prstGeom prst="rect">
-            <a:avLst/>
-          </a:prstGeom>
-          <a:noFill/>
-          <a:ln/>
-        </p:spPr>
-        <p:txBody>
-          <a:bodyPr wrap="square" lIns="0" tIns="0" rIns="0" bIns="0" rtlCol="0" anchor="ctr"/>
-          <a:lstStyle/>
-          <a:p>
-            <a:pPr indent="0" marL="0">
-              <a:buNone/>
-            </a:pPr>
-            <a:r>
-              <a:rPr lang="en-US" sz="1500" dirty="0">
-                <a:solidFill>
-                  <a:srgbClr val="5B6B79"/>
-                </a:solidFill>
-                <a:latin typeface="Calibri" pitchFamily="34" charset="0"/>
-                <a:ea typeface="Calibri" pitchFamily="34" charset="-122"/>
-                <a:cs typeface="Calibri" pitchFamily="34" charset="-120"/>
-              </a:rPr>
-              <a:t>Fully Arabic and English — including the AI's own writing, not just the interface. Every workflow and the copilot answer in the language of the request.</a:t>
-            </a:r>
-            <a:endParaRPr lang="en-US" sz="1500" dirty="0"/>
-          </a:p>
-        </p:txBody>
-      </p:sp>
-      <p:sp>
-        <p:nvSpPr>
-          <p:cNvPr id="4" name="Shape 2"/>
-          <p:cNvSpPr/>
-          <p:nvPr/>
-        </p:nvSpPr>
-        <p:spPr>
-          <a:xfrm>
-            <a:off x="548640" y="2286000"/>
-            <a:ext cx="2606040" cy="1600200"/>
+          <p:cNvPr id="3" name="Shape 1"/>
+          <p:cNvSpPr/>
+          <p:nvPr/>
+        </p:nvSpPr>
+        <p:spPr>
+          <a:xfrm>
+            <a:off x="548640" y="1417320"/>
+            <a:ext cx="1828800" cy="1371600"/>
           </a:xfrm>
           <a:prstGeom prst="roundRect">
             <a:avLst>
-              <a:gd name="adj" fmla="val 6857"/>
+              <a:gd name="adj" fmla="val 6667"/>
             </a:avLst>
           </a:prstGeom>
           <a:solidFill>
@@ -2926,14 +2940,53 @@
       </p:sp>
       <p:sp>
         <p:nvSpPr>
+          <p:cNvPr id="4" name="Text 2"/>
+          <p:cNvSpPr/>
+          <p:nvPr/>
+        </p:nvSpPr>
+        <p:spPr>
+          <a:xfrm>
+            <a:off x="548640" y="1554480"/>
+            <a:ext cx="1828800" cy="731520"/>
+          </a:xfrm>
+          <a:prstGeom prst="rect">
+            <a:avLst/>
+          </a:prstGeom>
+          <a:noFill/>
+          <a:ln/>
+        </p:spPr>
+        <p:txBody>
+          <a:bodyPr wrap="square" lIns="0" tIns="0" rIns="0" bIns="0" rtlCol="0" anchor="ctr"/>
+          <a:lstStyle/>
+          <a:p>
+            <a:pPr algn="ctr" indent="0" marL="0">
+              <a:buNone/>
+            </a:pPr>
+            <a:r>
+              <a:rPr lang="en-US" sz="3400" b="1" dirty="0">
+                <a:solidFill>
+                  <a:srgbClr val="E8622C"/>
+                </a:solidFill>
+                <a:latin typeface="Calibri" pitchFamily="34" charset="0"/>
+                <a:ea typeface="Calibri" pitchFamily="34" charset="-122"/>
+                <a:cs typeface="Calibri" pitchFamily="34" charset="-120"/>
+              </a:rPr>
+              <a:t>368</a:t>
+            </a:r>
+            <a:endParaRPr lang="en-US" sz="3400" dirty="0"/>
+          </a:p>
+        </p:txBody>
+      </p:sp>
+      <p:sp>
+        <p:nvSpPr>
           <p:cNvPr id="5" name="Text 3"/>
           <p:cNvSpPr/>
           <p:nvPr/>
         </p:nvSpPr>
         <p:spPr>
           <a:xfrm>
-            <a:off x="548640" y="2487168"/>
-            <a:ext cx="2606040" cy="868680"/>
+            <a:off x="640080" y="2331720"/>
+            <a:ext cx="1645920" cy="365760"/>
           </a:xfrm>
           <a:prstGeom prst="rect">
             <a:avLst/>
@@ -2949,46 +3002,7 @@
               <a:buNone/>
             </a:pPr>
             <a:r>
-              <a:rPr lang="en-US" sz="4400" b="1" dirty="0">
-                <a:solidFill>
-                  <a:srgbClr val="E8622C"/>
-                </a:solidFill>
-                <a:latin typeface="Calibri" pitchFamily="34" charset="0"/>
-                <a:ea typeface="Calibri" pitchFamily="34" charset="-122"/>
-                <a:cs typeface="Calibri" pitchFamily="34" charset="-120"/>
-              </a:rPr>
-              <a:t>368</a:t>
-            </a:r>
-            <a:endParaRPr lang="en-US" sz="4400" dirty="0"/>
-          </a:p>
-        </p:txBody>
-      </p:sp>
-      <p:sp>
-        <p:nvSpPr>
-          <p:cNvPr id="6" name="Text 4"/>
-          <p:cNvSpPr/>
-          <p:nvPr/>
-        </p:nvSpPr>
-        <p:spPr>
-          <a:xfrm>
-            <a:off x="685800" y="3383280"/>
-            <a:ext cx="2331720" cy="411480"/>
-          </a:xfrm>
-          <a:prstGeom prst="rect">
-            <a:avLst/>
-          </a:prstGeom>
-          <a:noFill/>
-          <a:ln/>
-        </p:spPr>
-        <p:txBody>
-          <a:bodyPr wrap="square" lIns="0" tIns="0" rIns="0" bIns="0" rtlCol="0" anchor="ctr"/>
-          <a:lstStyle/>
-          <a:p>
-            <a:pPr algn="ctr" indent="0" marL="0">
-              <a:buNone/>
-            </a:pPr>
-            <a:r>
-              <a:rPr lang="en-US" sz="1250" dirty="0">
+              <a:rPr lang="en-US" sz="1100" dirty="0">
                 <a:solidFill>
                   <a:srgbClr val="C7D2DE"/>
                 </a:solidFill>
@@ -2998,24 +3012,24 @@
               </a:rPr>
               <a:t>automated tests</a:t>
             </a:r>
-            <a:endParaRPr lang="en-US" sz="1250" dirty="0"/>
-          </a:p>
-        </p:txBody>
-      </p:sp>
-      <p:sp>
-        <p:nvSpPr>
-          <p:cNvPr id="7" name="Shape 5"/>
-          <p:cNvSpPr/>
-          <p:nvPr/>
-        </p:nvSpPr>
-        <p:spPr>
-          <a:xfrm>
-            <a:off x="3410712" y="2286000"/>
-            <a:ext cx="2606040" cy="1600200"/>
+            <a:endParaRPr lang="en-US" sz="1100" dirty="0"/>
+          </a:p>
+        </p:txBody>
+      </p:sp>
+      <p:sp>
+        <p:nvSpPr>
+          <p:cNvPr id="6" name="Shape 4"/>
+          <p:cNvSpPr/>
+          <p:nvPr/>
+        </p:nvSpPr>
+        <p:spPr>
+          <a:xfrm>
+            <a:off x="2560320" y="1417320"/>
+            <a:ext cx="1828800" cy="1371600"/>
           </a:xfrm>
           <a:prstGeom prst="roundRect">
             <a:avLst>
-              <a:gd name="adj" fmla="val 6857"/>
+              <a:gd name="adj" fmla="val 6667"/>
             </a:avLst>
           </a:prstGeom>
           <a:solidFill>
@@ -3026,14 +3040,53 @@
       </p:sp>
       <p:sp>
         <p:nvSpPr>
+          <p:cNvPr id="7" name="Text 5"/>
+          <p:cNvSpPr/>
+          <p:nvPr/>
+        </p:nvSpPr>
+        <p:spPr>
+          <a:xfrm>
+            <a:off x="2560320" y="1554480"/>
+            <a:ext cx="1828800" cy="731520"/>
+          </a:xfrm>
+          <a:prstGeom prst="rect">
+            <a:avLst/>
+          </a:prstGeom>
+          <a:noFill/>
+          <a:ln/>
+        </p:spPr>
+        <p:txBody>
+          <a:bodyPr wrap="square" lIns="0" tIns="0" rIns="0" bIns="0" rtlCol="0" anchor="ctr"/>
+          <a:lstStyle/>
+          <a:p>
+            <a:pPr algn="ctr" indent="0" marL="0">
+              <a:buNone/>
+            </a:pPr>
+            <a:r>
+              <a:rPr lang="en-US" sz="3400" b="1" dirty="0">
+                <a:solidFill>
+                  <a:srgbClr val="132A46"/>
+                </a:solidFill>
+                <a:latin typeface="Calibri" pitchFamily="34" charset="0"/>
+                <a:ea typeface="Calibri" pitchFamily="34" charset="-122"/>
+                <a:cs typeface="Calibri" pitchFamily="34" charset="-120"/>
+              </a:rPr>
+              <a:t>41</a:t>
+            </a:r>
+            <a:endParaRPr lang="en-US" sz="3400" dirty="0"/>
+          </a:p>
+        </p:txBody>
+      </p:sp>
+      <p:sp>
+        <p:nvSpPr>
           <p:cNvPr id="8" name="Text 6"/>
           <p:cNvSpPr/>
           <p:nvPr/>
         </p:nvSpPr>
         <p:spPr>
           <a:xfrm>
-            <a:off x="3410712" y="2487168"/>
-            <a:ext cx="2606040" cy="868680"/>
+            <a:off x="2651760" y="2331720"/>
+            <a:ext cx="1645920" cy="365760"/>
           </a:xfrm>
           <a:prstGeom prst="rect">
             <a:avLst/>
@@ -3049,46 +3102,7 @@
               <a:buNone/>
             </a:pPr>
             <a:r>
-              <a:rPr lang="en-US" sz="4400" b="1" dirty="0">
-                <a:solidFill>
-                  <a:srgbClr val="132A46"/>
-                </a:solidFill>
-                <a:latin typeface="Calibri" pitchFamily="34" charset="0"/>
-                <a:ea typeface="Calibri" pitchFamily="34" charset="-122"/>
-                <a:cs typeface="Calibri" pitchFamily="34" charset="-120"/>
-              </a:rPr>
-              <a:t>41</a:t>
-            </a:r>
-            <a:endParaRPr lang="en-US" sz="4400" dirty="0"/>
-          </a:p>
-        </p:txBody>
-      </p:sp>
-      <p:sp>
-        <p:nvSpPr>
-          <p:cNvPr id="9" name="Text 7"/>
-          <p:cNvSpPr/>
-          <p:nvPr/>
-        </p:nvSpPr>
-        <p:spPr>
-          <a:xfrm>
-            <a:off x="3547872" y="3383280"/>
-            <a:ext cx="2331720" cy="411480"/>
-          </a:xfrm>
-          <a:prstGeom prst="rect">
-            <a:avLst/>
-          </a:prstGeom>
-          <a:noFill/>
-          <a:ln/>
-        </p:spPr>
-        <p:txBody>
-          <a:bodyPr wrap="square" lIns="0" tIns="0" rIns="0" bIns="0" rtlCol="0" anchor="ctr"/>
-          <a:lstStyle/>
-          <a:p>
-            <a:pPr algn="ctr" indent="0" marL="0">
-              <a:buNone/>
-            </a:pPr>
-            <a:r>
-              <a:rPr lang="en-US" sz="1250" dirty="0">
+              <a:rPr lang="en-US" sz="1100" dirty="0">
                 <a:solidFill>
                   <a:srgbClr val="5B6B79"/>
                 </a:solidFill>
@@ -3098,24 +3112,24 @@
               </a:rPr>
               <a:t>database tables</a:t>
             </a:r>
-            <a:endParaRPr lang="en-US" sz="1250" dirty="0"/>
-          </a:p>
-        </p:txBody>
-      </p:sp>
-      <p:sp>
-        <p:nvSpPr>
-          <p:cNvPr id="10" name="Shape 8"/>
-          <p:cNvSpPr/>
-          <p:nvPr/>
-        </p:nvSpPr>
-        <p:spPr>
-          <a:xfrm>
-            <a:off x="6272784" y="2286000"/>
-            <a:ext cx="2606040" cy="1600200"/>
+            <a:endParaRPr lang="en-US" sz="1100" dirty="0"/>
+          </a:p>
+        </p:txBody>
+      </p:sp>
+      <p:sp>
+        <p:nvSpPr>
+          <p:cNvPr id="9" name="Shape 7"/>
+          <p:cNvSpPr/>
+          <p:nvPr/>
+        </p:nvSpPr>
+        <p:spPr>
+          <a:xfrm>
+            <a:off x="4572000" y="1417320"/>
+            <a:ext cx="1828800" cy="1371600"/>
           </a:xfrm>
           <a:prstGeom prst="roundRect">
             <a:avLst>
-              <a:gd name="adj" fmla="val 6857"/>
+              <a:gd name="adj" fmla="val 6667"/>
             </a:avLst>
           </a:prstGeom>
           <a:solidFill>
@@ -3126,14 +3140,53 @@
       </p:sp>
       <p:sp>
         <p:nvSpPr>
+          <p:cNvPr id="10" name="Text 8"/>
+          <p:cNvSpPr/>
+          <p:nvPr/>
+        </p:nvSpPr>
+        <p:spPr>
+          <a:xfrm>
+            <a:off x="4572000" y="1554480"/>
+            <a:ext cx="1828800" cy="731520"/>
+          </a:xfrm>
+          <a:prstGeom prst="rect">
+            <a:avLst/>
+          </a:prstGeom>
+          <a:noFill/>
+          <a:ln/>
+        </p:spPr>
+        <p:txBody>
+          <a:bodyPr wrap="square" lIns="0" tIns="0" rIns="0" bIns="0" rtlCol="0" anchor="ctr"/>
+          <a:lstStyle/>
+          <a:p>
+            <a:pPr algn="ctr" indent="0" marL="0">
+              <a:buNone/>
+            </a:pPr>
+            <a:r>
+              <a:rPr lang="en-US" sz="3400" b="1" dirty="0">
+                <a:solidFill>
+                  <a:srgbClr val="E8622C"/>
+                </a:solidFill>
+                <a:latin typeface="Calibri" pitchFamily="34" charset="0"/>
+                <a:ea typeface="Calibri" pitchFamily="34" charset="-122"/>
+                <a:cs typeface="Calibri" pitchFamily="34" charset="-120"/>
+              </a:rPr>
+              <a:t>9</a:t>
+            </a:r>
+            <a:endParaRPr lang="en-US" sz="3400" dirty="0"/>
+          </a:p>
+        </p:txBody>
+      </p:sp>
+      <p:sp>
+        <p:nvSpPr>
           <p:cNvPr id="11" name="Text 9"/>
           <p:cNvSpPr/>
           <p:nvPr/>
         </p:nvSpPr>
         <p:spPr>
           <a:xfrm>
-            <a:off x="6272784" y="2487168"/>
-            <a:ext cx="2606040" cy="868680"/>
+            <a:off x="4663440" y="2331720"/>
+            <a:ext cx="1645920" cy="365760"/>
           </a:xfrm>
           <a:prstGeom prst="rect">
             <a:avLst/>
@@ -3149,46 +3202,7 @@
               <a:buNone/>
             </a:pPr>
             <a:r>
-              <a:rPr lang="en-US" sz="4400" b="1" dirty="0">
-                <a:solidFill>
-                  <a:srgbClr val="E8622C"/>
-                </a:solidFill>
-                <a:latin typeface="Calibri" pitchFamily="34" charset="0"/>
-                <a:ea typeface="Calibri" pitchFamily="34" charset="-122"/>
-                <a:cs typeface="Calibri" pitchFamily="34" charset="-120"/>
-              </a:rPr>
-              <a:t>9</a:t>
-            </a:r>
-            <a:endParaRPr lang="en-US" sz="4400" dirty="0"/>
-          </a:p>
-        </p:txBody>
-      </p:sp>
-      <p:sp>
-        <p:nvSpPr>
-          <p:cNvPr id="12" name="Text 10"/>
-          <p:cNvSpPr/>
-          <p:nvPr/>
-        </p:nvSpPr>
-        <p:spPr>
-          <a:xfrm>
-            <a:off x="6409944" y="3383280"/>
-            <a:ext cx="2331720" cy="411480"/>
-          </a:xfrm>
-          <a:prstGeom prst="rect">
-            <a:avLst/>
-          </a:prstGeom>
-          <a:noFill/>
-          <a:ln/>
-        </p:spPr>
-        <p:txBody>
-          <a:bodyPr wrap="square" lIns="0" tIns="0" rIns="0" bIns="0" rtlCol="0" anchor="ctr"/>
-          <a:lstStyle/>
-          <a:p>
-            <a:pPr algn="ctr" indent="0" marL="0">
-              <a:buNone/>
-            </a:pPr>
-            <a:r>
-              <a:rPr lang="en-US" sz="1250" dirty="0">
+              <a:rPr lang="en-US" sz="1100" dirty="0">
                 <a:solidFill>
                   <a:srgbClr val="C7D2DE"/>
                 </a:solidFill>
@@ -3198,24 +3212,24 @@
               </a:rPr>
               <a:t>functional modules</a:t>
             </a:r>
-            <a:endParaRPr lang="en-US" sz="1250" dirty="0"/>
-          </a:p>
-        </p:txBody>
-      </p:sp>
-      <p:sp>
-        <p:nvSpPr>
-          <p:cNvPr id="13" name="Shape 11"/>
-          <p:cNvSpPr/>
-          <p:nvPr/>
-        </p:nvSpPr>
-        <p:spPr>
-          <a:xfrm>
-            <a:off x="9134856" y="2286000"/>
-            <a:ext cx="2606040" cy="1600200"/>
+            <a:endParaRPr lang="en-US" sz="1100" dirty="0"/>
+          </a:p>
+        </p:txBody>
+      </p:sp>
+      <p:sp>
+        <p:nvSpPr>
+          <p:cNvPr id="12" name="Shape 10"/>
+          <p:cNvSpPr/>
+          <p:nvPr/>
+        </p:nvSpPr>
+        <p:spPr>
+          <a:xfrm>
+            <a:off x="6583680" y="1417320"/>
+            <a:ext cx="1828800" cy="1371600"/>
           </a:xfrm>
           <a:prstGeom prst="roundRect">
             <a:avLst>
-              <a:gd name="adj" fmla="val 6857"/>
+              <a:gd name="adj" fmla="val 6667"/>
             </a:avLst>
           </a:prstGeom>
           <a:solidFill>
@@ -3226,14 +3240,53 @@
       </p:sp>
       <p:sp>
         <p:nvSpPr>
+          <p:cNvPr id="13" name="Text 11"/>
+          <p:cNvSpPr/>
+          <p:nvPr/>
+        </p:nvSpPr>
+        <p:spPr>
+          <a:xfrm>
+            <a:off x="6583680" y="1554480"/>
+            <a:ext cx="1828800" cy="731520"/>
+          </a:xfrm>
+          <a:prstGeom prst="rect">
+            <a:avLst/>
+          </a:prstGeom>
+          <a:noFill/>
+          <a:ln/>
+        </p:spPr>
+        <p:txBody>
+          <a:bodyPr wrap="square" lIns="0" tIns="0" rIns="0" bIns="0" rtlCol="0" anchor="ctr"/>
+          <a:lstStyle/>
+          <a:p>
+            <a:pPr algn="ctr" indent="0" marL="0">
+              <a:buNone/>
+            </a:pPr>
+            <a:r>
+              <a:rPr lang="en-US" sz="3400" b="1" dirty="0">
+                <a:solidFill>
+                  <a:srgbClr val="132A46"/>
+                </a:solidFill>
+                <a:latin typeface="Calibri" pitchFamily="34" charset="0"/>
+                <a:ea typeface="Calibri" pitchFamily="34" charset="-122"/>
+                <a:cs typeface="Calibri" pitchFamily="34" charset="-120"/>
+              </a:rPr>
+              <a:t>7</a:t>
+            </a:r>
+            <a:endParaRPr lang="en-US" sz="3400" dirty="0"/>
+          </a:p>
+        </p:txBody>
+      </p:sp>
+      <p:sp>
+        <p:nvSpPr>
           <p:cNvPr id="14" name="Text 12"/>
           <p:cNvSpPr/>
           <p:nvPr/>
         </p:nvSpPr>
         <p:spPr>
           <a:xfrm>
-            <a:off x="9134856" y="2487168"/>
-            <a:ext cx="2606040" cy="868680"/>
+            <a:off x="6675120" y="2331720"/>
+            <a:ext cx="1645920" cy="365760"/>
           </a:xfrm>
           <a:prstGeom prst="rect">
             <a:avLst/>
@@ -3249,17 +3302,17 @@
               <a:buNone/>
             </a:pPr>
             <a:r>
-              <a:rPr lang="en-US" sz="4400" b="1" dirty="0">
-                <a:solidFill>
-                  <a:srgbClr val="132A46"/>
-                </a:solidFill>
-                <a:latin typeface="Calibri" pitchFamily="34" charset="0"/>
-                <a:ea typeface="Calibri" pitchFamily="34" charset="-122"/>
-                <a:cs typeface="Calibri" pitchFamily="34" charset="-120"/>
-              </a:rPr>
-              <a:t>7</a:t>
-            </a:r>
-            <a:endParaRPr lang="en-US" sz="4400" dirty="0"/>
+              <a:rPr lang="en-US" sz="1100" dirty="0">
+                <a:solidFill>
+                  <a:srgbClr val="5B6B79"/>
+                </a:solidFill>
+                <a:latin typeface="Calibri" pitchFamily="34" charset="0"/>
+                <a:ea typeface="Calibri" pitchFamily="34" charset="-122"/>
+                <a:cs typeface="Calibri" pitchFamily="34" charset="-120"/>
+              </a:rPr>
+              <a:t>RBAC roles</a:t>
+            </a:r>
+            <a:endParaRPr lang="en-US" sz="1100" dirty="0"/>
           </a:p>
         </p:txBody>
       </p:sp>
@@ -3271,24 +3324,27 @@
         </p:nvSpPr>
         <p:spPr>
           <a:xfrm>
-            <a:off x="9272016" y="3383280"/>
-            <a:ext cx="2331720" cy="411480"/>
-          </a:xfrm>
-          <a:prstGeom prst="rect">
-            <a:avLst/>
-          </a:prstGeom>
-          <a:noFill/>
-          <a:ln/>
-        </p:spPr>
-        <p:txBody>
-          <a:bodyPr wrap="square" lIns="0" tIns="0" rIns="0" bIns="0" rtlCol="0" anchor="ctr"/>
-          <a:lstStyle/>
-          <a:p>
-            <a:pPr algn="ctr" indent="0" marL="0">
-              <a:buNone/>
-            </a:pPr>
-            <a:r>
-              <a:rPr lang="en-US" sz="1250" dirty="0">
+            <a:off x="548640" y="3063240"/>
+            <a:ext cx="4206240" cy="3200400"/>
+          </a:xfrm>
+          <a:prstGeom prst="rect">
+            <a:avLst/>
+          </a:prstGeom>
+          <a:noFill/>
+          <a:ln/>
+        </p:spPr>
+        <p:txBody>
+          <a:bodyPr wrap="square" lIns="0" tIns="0" rIns="0" bIns="0" rtlCol="0" anchor="ctr"/>
+          <a:lstStyle/>
+          <a:p>
+            <a:pPr indent="0" marL="0">
+              <a:lnSpc>
+                <a:spcPct val="135000"/>
+              </a:lnSpc>
+              <a:buNone/>
+            </a:pPr>
+            <a:r>
+              <a:rPr lang="en-US" sz="1350" dirty="0">
                 <a:solidFill>
                   <a:srgbClr val="5B6B79"/>
                 </a:solidFill>
@@ -3296,9 +3352,9 @@
                 <a:ea typeface="Calibri" pitchFamily="34" charset="-122"/>
                 <a:cs typeface="Calibri" pitchFamily="34" charset="-120"/>
               </a:rPr>
-              <a:t>RBAC roles</a:t>
-            </a:r>
-            <a:endParaRPr lang="en-US" sz="1250" dirty="0"/>
+              <a:t>Arabic runs right-to-left throughout the interface, and AI-generated reports, reviews, and summaries are written natively in the language of the request — not machine-translated afterward. CI runs lint, typecheck, build, and translation-parity checks on every change.</a:t>
+            </a:r>
+            <a:endParaRPr lang="en-US" sz="1350" dirty="0"/>
           </a:p>
         </p:txBody>
       </p:sp>
@@ -3310,21 +3366,35 @@
         </p:nvSpPr>
         <p:spPr>
           <a:xfrm>
-            <a:off x="548640" y="4434840"/>
-            <a:ext cx="566928" cy="566928"/>
-          </a:xfrm>
-          <a:prstGeom prst="ellipse">
-            <a:avLst/>
+            <a:off x="5548155" y="3017520"/>
+            <a:ext cx="5664642" cy="2971800"/>
+          </a:xfrm>
+          <a:prstGeom prst="roundRect">
+            <a:avLst>
+              <a:gd name="adj" fmla="val 2462"/>
+            </a:avLst>
           </a:prstGeom>
           <a:solidFill>
-            <a:srgbClr val="E8622C"/>
+            <a:srgbClr val="FFFFFF"/>
           </a:solidFill>
-          <a:ln/>
+          <a:ln w="12700">
+            <a:solidFill>
+              <a:srgbClr val="E2E6EA"/>
+            </a:solidFill>
+            <a:prstDash val="solid"/>
+          </a:ln>
+          <a:effectLst>
+            <a:outerShdw sx="100000" sy="100000" kx="0" ky="0" algn="bl" rotWithShape="0" blurRad="127000" dist="38100" dir="5400000">
+              <a:srgbClr val="1F2937">
+                <a:alpha val="18000"/>
+              </a:srgbClr>
+            </a:outerShdw>
+          </a:effectLst>
         </p:spPr>
       </p:sp>
       <p:pic>
         <p:nvPicPr>
-          <p:cNvPr id="17" name="Image 0" descr="preencoded.png">    </p:cNvPr>
+          <p:cNvPr id="17" name="Image 0" descr="The dashboard shown fully right-to-left in Arabic">    </p:cNvPr>
           <p:cNvPicPr>
             <a:picLocks noChangeAspect="1"/>
           </p:cNvPicPr>
@@ -3338,8 +3408,8 @@
         </p:blipFill>
         <p:spPr>
           <a:xfrm>
-            <a:off x="676199" y="4562399"/>
-            <a:ext cx="311810" cy="311810"/>
+            <a:off x="5593875" y="3063240"/>
+            <a:ext cx="5573202" cy="2880360"/>
           </a:xfrm>
           <a:prstGeom prst="rect">
             <a:avLst/>
@@ -3354,89 +3424,24 @@
         </p:nvSpPr>
         <p:spPr>
           <a:xfrm>
-            <a:off x="1325880" y="4389120"/>
-            <a:ext cx="10317175" cy="731520"/>
-          </a:xfrm>
-          <a:prstGeom prst="rect">
-            <a:avLst/>
-          </a:prstGeom>
-          <a:noFill/>
-          <a:ln/>
-        </p:spPr>
-        <p:txBody>
-          <a:bodyPr wrap="square" lIns="0" tIns="0" rIns="0" bIns="0" rtlCol="0" anchor="ctr"/>
-          <a:lstStyle/>
-          <a:p>
-            <a:pPr indent="0" marL="0">
-              <a:lnSpc>
-                <a:spcPct val="130000"/>
-              </a:lnSpc>
-              <a:buNone/>
-            </a:pPr>
-            <a:r>
-              <a:rPr lang="en-US" sz="1300" dirty="0">
-                <a:solidFill>
-                  <a:srgbClr val="132A46"/>
-                </a:solidFill>
-                <a:latin typeface="Calibri" pitchFamily="34" charset="0"/>
-                <a:ea typeface="Calibri" pitchFamily="34" charset="-122"/>
-                <a:cs typeface="Calibri" pitchFamily="34" charset="-120"/>
-              </a:rPr>
-              <a:t>Arabic runs right-to-left throughout the interface, and AI-generated reports, reviews, and summaries are written natively in the language of the request — not machine-translated afterward.</a:t>
-            </a:r>
-            <a:endParaRPr lang="en-US" sz="1300" dirty="0"/>
-          </a:p>
-        </p:txBody>
-      </p:sp>
-      <p:sp>
-        <p:nvSpPr>
-          <p:cNvPr id="19" name="Shape 16"/>
-          <p:cNvSpPr/>
-          <p:nvPr/>
-        </p:nvSpPr>
-        <p:spPr>
-          <a:xfrm>
-            <a:off x="548640" y="5532120"/>
-            <a:ext cx="11094415" cy="0"/>
-          </a:xfrm>
-          <a:prstGeom prst="line">
-            <a:avLst/>
-          </a:prstGeom>
-          <a:noFill/>
-          <a:ln w="12700">
-            <a:solidFill>
-              <a:srgbClr val="E2E6EA"/>
-            </a:solidFill>
-            <a:prstDash val="solid"/>
-          </a:ln>
-        </p:spPr>
-      </p:sp>
-      <p:sp>
-        <p:nvSpPr>
-          <p:cNvPr id="20" name="Text 17"/>
-          <p:cNvSpPr/>
-          <p:nvPr/>
-        </p:nvSpPr>
-        <p:spPr>
-          <a:xfrm>
-            <a:off x="548640" y="5669280"/>
-            <a:ext cx="11094415" cy="365760"/>
-          </a:xfrm>
-          <a:prstGeom prst="rect">
-            <a:avLst/>
-          </a:prstGeom>
-          <a:noFill/>
-          <a:ln/>
-        </p:spPr>
-        <p:txBody>
-          <a:bodyPr wrap="square" lIns="0" tIns="0" rIns="0" bIns="0" rtlCol="0" anchor="ctr"/>
-          <a:lstStyle/>
-          <a:p>
-            <a:pPr indent="0" marL="0">
-              <a:buNone/>
-            </a:pPr>
-            <a:r>
-              <a:rPr lang="en-US" sz="1150" i="1" dirty="0">
+            <a:off x="5593875" y="6035040"/>
+            <a:ext cx="5573202" cy="274320"/>
+          </a:xfrm>
+          <a:prstGeom prst="rect">
+            <a:avLst/>
+          </a:prstGeom>
+          <a:noFill/>
+          <a:ln/>
+        </p:spPr>
+        <p:txBody>
+          <a:bodyPr wrap="square" lIns="0" tIns="0" rIns="0" bIns="0" rtlCol="0" anchor="ctr"/>
+          <a:lstStyle/>
+          <a:p>
+            <a:pPr algn="ctr" indent="0" marL="0">
+              <a:buNone/>
+            </a:pPr>
+            <a:r>
+              <a:rPr lang="en-US" sz="1100" i="1" dirty="0">
                 <a:solidFill>
                   <a:srgbClr val="8A97A3"/>
                 </a:solidFill>
@@ -3444,15 +3449,15 @@
                 <a:ea typeface="Calibri" pitchFamily="34" charset="-122"/>
                 <a:cs typeface="Calibri" pitchFamily="34" charset="-120"/>
               </a:rPr>
-              <a:t>CI runs lint, typecheck, build, and translation-parity checks on every change.</a:t>
-            </a:r>
-            <a:endParaRPr lang="en-US" sz="1150" dirty="0"/>
-          </a:p>
-        </p:txBody>
-      </p:sp>
-      <p:sp>
-        <p:nvSpPr>
-          <p:cNvPr id="21" name="Text 18"/>
+              <a:t>The same interface, fully right-to-left</a:t>
+            </a:r>
+            <a:endParaRPr lang="en-US" sz="1100" dirty="0"/>
+          </a:p>
+        </p:txBody>
+      </p:sp>
+      <p:sp>
+        <p:nvSpPr>
+          <p:cNvPr id="19" name="Text 16"/>
           <p:cNvSpPr/>
           <p:nvPr/>
         </p:nvSpPr>
@@ -3471,7 +3476,7 @@
           <a:bodyPr wrap="square" lIns="0" tIns="0" rIns="0" bIns="0" rtlCol="0" anchor="ctr"/>
           <a:lstStyle/>
           <a:p>
-            <a:pPr algn="l" indent="0" marL="0">
+            <a:pPr indent="0" marL="0">
               <a:buNone/>
             </a:pPr>
             <a:r>
@@ -3491,7 +3496,7 @@
       </p:sp>
       <p:sp>
         <p:nvSpPr>
-          <p:cNvPr id="22" name="Text 19"/>
+          <p:cNvPr id="20" name="Text 17"/>
           <p:cNvSpPr/>
           <p:nvPr/>
         </p:nvSpPr>
@@ -4262,7 +4267,7 @@
                 <a:ea typeface="Calibri" pitchFamily="34" charset="-122"/>
                 <a:cs typeface="Calibri" pitchFamily="34" charset="-120"/>
               </a:rPr>
-              <a:t>Local, Groq, or Gemini — one env variable</a:t>
+              <a:t>Gemini, Groq, OpenAI, or local — one env variable</a:t>
             </a:r>
             <a:endParaRPr lang="en-US" sz="1250" dirty="0"/>
           </a:p>
@@ -4289,7 +4294,7 @@
           <a:bodyPr wrap="square" lIns="0" tIns="0" rIns="0" bIns="0" rtlCol="0" anchor="ctr"/>
           <a:lstStyle/>
           <a:p>
-            <a:pPr algn="l" indent="0" marL="0">
+            <a:pPr indent="0" marL="0">
               <a:buNone/>
             </a:pPr>
             <a:r>
@@ -5597,7 +5602,7 @@
           <a:bodyPr wrap="square" lIns="0" tIns="0" rIns="0" bIns="0" rtlCol="0" anchor="ctr"/>
           <a:lstStyle/>
           <a:p>
-            <a:pPr algn="l" indent="0" marL="0">
+            <a:pPr indent="0" marL="0">
               <a:buNone/>
             </a:pPr>
             <a:r>
@@ -5733,8 +5738,8 @@
         </p:nvSpPr>
         <p:spPr>
           <a:xfrm>
-            <a:off x="548640" y="1463040"/>
-            <a:ext cx="11094415" cy="1188720"/>
+            <a:off x="548640" y="1371600"/>
+            <a:ext cx="11094415" cy="960120"/>
           </a:xfrm>
           <a:prstGeom prst="rect">
             <a:avLst/>
@@ -5748,12 +5753,12 @@
           <a:p>
             <a:pPr indent="0" marL="0">
               <a:lnSpc>
-                <a:spcPct val="135000"/>
+                <a:spcPct val="130000"/>
               </a:lnSpc>
               <a:buNone/>
             </a:pPr>
             <a:r>
-              <a:rPr lang="en-US" sz="1550" dirty="0">
+              <a:rPr lang="en-US" sz="1450" dirty="0">
                 <a:solidFill>
                   <a:srgbClr val="5B6B79"/>
                 </a:solidFill>
@@ -5761,9 +5766,9 @@
                 <a:ea typeface="Calibri" pitchFamily="34" charset="-122"/>
                 <a:cs typeface="Calibri" pitchFamily="34" charset="-120"/>
               </a:rPr>
-              <a:t>The platform ingests real project data, keeps an organizational memory of what was decided and why, runs AI workflows over the operational record, and answers management's questions — every AI answer traced back to the records it came from, every high-risk action held behind human approval.</a:t>
-            </a:r>
-            <a:endParaRPr lang="en-US" sz="1550" dirty="0"/>
+              <a:t>The platform ingests project data, keeps an organizational memory of what was decided and why, runs AI workflows over the operational record, and answers management's questions — every AI answer traced back to the records it came from, every high-risk action held behind human approval.</a:t>
+            </a:r>
+            <a:endParaRPr lang="en-US" sz="1450" dirty="0"/>
           </a:p>
         </p:txBody>
       </p:sp>
@@ -5775,43 +5780,35 @@
         </p:nvSpPr>
         <p:spPr>
           <a:xfrm>
-            <a:off x="548640" y="2971800"/>
-            <a:ext cx="2606040" cy="2743200"/>
+            <a:off x="502920" y="2785260"/>
+            <a:ext cx="5349240" cy="2567641"/>
           </a:xfrm>
           <a:prstGeom prst="roundRect">
             <a:avLst>
-              <a:gd name="adj" fmla="val 4211"/>
+              <a:gd name="adj" fmla="val 2849"/>
             </a:avLst>
           </a:prstGeom>
           <a:solidFill>
-            <a:srgbClr val="F4F6F8"/>
+            <a:srgbClr val="FFFFFF"/>
           </a:solidFill>
-          <a:ln/>
-        </p:spPr>
-      </p:sp>
-      <p:sp>
-        <p:nvSpPr>
-          <p:cNvPr id="5" name="Shape 3"/>
-          <p:cNvSpPr/>
-          <p:nvPr/>
-        </p:nvSpPr>
-        <p:spPr>
-          <a:xfrm>
-            <a:off x="1485900" y="3291840"/>
-            <a:ext cx="731520" cy="731520"/>
-          </a:xfrm>
-          <a:prstGeom prst="ellipse">
-            <a:avLst/>
-          </a:prstGeom>
-          <a:solidFill>
-            <a:srgbClr val="132A46"/>
-          </a:solidFill>
-          <a:ln/>
+          <a:ln w="12700">
+            <a:solidFill>
+              <a:srgbClr val="E2E6EA"/>
+            </a:solidFill>
+            <a:prstDash val="solid"/>
+          </a:ln>
+          <a:effectLst>
+            <a:outerShdw sx="100000" sy="100000" kx="0" ky="0" algn="bl" rotWithShape="0" blurRad="127000" dist="38100" dir="5400000">
+              <a:srgbClr val="1F2937">
+                <a:alpha val="18000"/>
+              </a:srgbClr>
+            </a:outerShdw>
+          </a:effectLst>
         </p:spPr>
       </p:sp>
       <p:pic>
         <p:nvPicPr>
-          <p:cNvPr id="6" name="Image 0" descr="preencoded.png">    </p:cNvPr>
+          <p:cNvPr id="5" name="Image 0" descr="Executive Dashboard showing portfolio KPIs">    </p:cNvPr>
           <p:cNvPicPr>
             <a:picLocks noChangeAspect="1"/>
           </p:cNvPicPr>
@@ -5825,8 +5822,8 @@
         </p:blipFill>
         <p:spPr>
           <a:xfrm>
-            <a:off x="1650492" y="3456432"/>
-            <a:ext cx="402336" cy="402336"/>
+            <a:off x="548640" y="2830980"/>
+            <a:ext cx="5257800" cy="2476201"/>
           </a:xfrm>
           <a:prstGeom prst="rect">
             <a:avLst/>
@@ -5835,130 +5832,80 @@
       </p:pic>
       <p:sp>
         <p:nvSpPr>
-          <p:cNvPr id="7" name="Text 4"/>
-          <p:cNvSpPr/>
-          <p:nvPr/>
-        </p:nvSpPr>
-        <p:spPr>
-          <a:xfrm>
-            <a:off x="713232" y="4206240"/>
-            <a:ext cx="2276856" cy="502920"/>
-          </a:xfrm>
-          <a:prstGeom prst="rect">
-            <a:avLst/>
-          </a:prstGeom>
-          <a:noFill/>
-          <a:ln/>
-        </p:spPr>
-        <p:txBody>
-          <a:bodyPr wrap="square" lIns="0" tIns="0" rIns="0" bIns="0" rtlCol="0" anchor="ctr"/>
-          <a:lstStyle/>
-          <a:p>
-            <a:pPr algn="ctr" indent="0" marL="0">
-              <a:buNone/>
-            </a:pPr>
-            <a:r>
-              <a:rPr lang="en-US" sz="1500" b="1" dirty="0">
-                <a:solidFill>
-                  <a:srgbClr val="132A46"/>
-                </a:solidFill>
-                <a:latin typeface="Calibri" pitchFamily="34" charset="0"/>
-                <a:ea typeface="Calibri" pitchFamily="34" charset="-122"/>
-                <a:cs typeface="Calibri" pitchFamily="34" charset="-120"/>
-              </a:rPr>
-              <a:t>Operational Record</a:t>
-            </a:r>
-            <a:endParaRPr lang="en-US" sz="1500" dirty="0"/>
-          </a:p>
-        </p:txBody>
-      </p:sp>
-      <p:sp>
-        <p:nvSpPr>
-          <p:cNvPr id="8" name="Text 5"/>
-          <p:cNvSpPr/>
-          <p:nvPr/>
-        </p:nvSpPr>
-        <p:spPr>
-          <a:xfrm>
-            <a:off x="749808" y="4709160"/>
-            <a:ext cx="2203704" cy="914400"/>
-          </a:xfrm>
-          <a:prstGeom prst="rect">
-            <a:avLst/>
-          </a:prstGeom>
-          <a:noFill/>
-          <a:ln/>
-        </p:spPr>
-        <p:txBody>
-          <a:bodyPr wrap="square" lIns="0" tIns="0" rIns="0" bIns="0" rtlCol="0" anchor="ctr"/>
-          <a:lstStyle/>
-          <a:p>
-            <a:pPr algn="ctr" indent="0" marL="0">
-              <a:lnSpc>
-                <a:spcPct val="125000"/>
-              </a:lnSpc>
-              <a:buNone/>
-            </a:pPr>
-            <a:r>
-              <a:rPr lang="en-US" sz="1150" dirty="0">
-                <a:solidFill>
-                  <a:srgbClr val="5B6B79"/>
-                </a:solidFill>
-                <a:latin typeface="Calibri" pitchFamily="34" charset="0"/>
-                <a:ea typeface="Calibri" pitchFamily="34" charset="-122"/>
-                <a:cs typeface="Calibri" pitchFamily="34" charset="-120"/>
-              </a:rPr>
-              <a:t>Every project, RFI, claim, and change order queryable in one place.</a:t>
-            </a:r>
-            <a:endParaRPr lang="en-US" sz="1150" dirty="0"/>
-          </a:p>
-        </p:txBody>
-      </p:sp>
-      <p:sp>
-        <p:nvSpPr>
-          <p:cNvPr id="9" name="Shape 6"/>
-          <p:cNvSpPr/>
-          <p:nvPr/>
-        </p:nvSpPr>
-        <p:spPr>
-          <a:xfrm>
-            <a:off x="3410712" y="2971800"/>
-            <a:ext cx="2606040" cy="2743200"/>
+          <p:cNvPr id="6" name="Text 3"/>
+          <p:cNvSpPr/>
+          <p:nvPr/>
+        </p:nvSpPr>
+        <p:spPr>
+          <a:xfrm>
+            <a:off x="548640" y="5416908"/>
+            <a:ext cx="5257800" cy="320040"/>
+          </a:xfrm>
+          <a:prstGeom prst="rect">
+            <a:avLst/>
+          </a:prstGeom>
+          <a:noFill/>
+          <a:ln/>
+        </p:spPr>
+        <p:txBody>
+          <a:bodyPr wrap="square" lIns="0" tIns="0" rIns="0" bIns="0" rtlCol="0" anchor="ctr"/>
+          <a:lstStyle/>
+          <a:p>
+            <a:pPr indent="0" marL="0">
+              <a:buNone/>
+            </a:pPr>
+            <a:r>
+              <a:rPr lang="en-US" sz="1100" i="1" dirty="0">
+                <a:solidFill>
+                  <a:srgbClr val="8A97A3"/>
+                </a:solidFill>
+                <a:latin typeface="Calibri" pitchFamily="34" charset="0"/>
+                <a:ea typeface="Calibri" pitchFamily="34" charset="-122"/>
+                <a:cs typeface="Calibri" pitchFamily="34" charset="-120"/>
+              </a:rPr>
+              <a:t>Executive Dashboard — real portfolio KPIs at a glance</a:t>
+            </a:r>
+            <a:endParaRPr lang="en-US" sz="1100" dirty="0"/>
+          </a:p>
+        </p:txBody>
+      </p:sp>
+      <p:sp>
+        <p:nvSpPr>
+          <p:cNvPr id="7" name="Shape 4"/>
+          <p:cNvSpPr/>
+          <p:nvPr/>
+        </p:nvSpPr>
+        <p:spPr>
+          <a:xfrm>
+            <a:off x="6126480" y="2652360"/>
+            <a:ext cx="5349240" cy="2833441"/>
           </a:xfrm>
           <a:prstGeom prst="roundRect">
             <a:avLst>
-              <a:gd name="adj" fmla="val 4211"/>
+              <a:gd name="adj" fmla="val 2582"/>
             </a:avLst>
           </a:prstGeom>
           <a:solidFill>
-            <a:srgbClr val="F4F6F8"/>
+            <a:srgbClr val="FFFFFF"/>
           </a:solidFill>
-          <a:ln/>
-        </p:spPr>
-      </p:sp>
-      <p:sp>
-        <p:nvSpPr>
-          <p:cNvPr id="10" name="Shape 7"/>
-          <p:cNvSpPr/>
-          <p:nvPr/>
-        </p:nvSpPr>
-        <p:spPr>
-          <a:xfrm>
-            <a:off x="4347972" y="3291840"/>
-            <a:ext cx="731520" cy="731520"/>
-          </a:xfrm>
-          <a:prstGeom prst="ellipse">
-            <a:avLst/>
-          </a:prstGeom>
-          <a:solidFill>
-            <a:srgbClr val="E8622C"/>
-          </a:solidFill>
-          <a:ln/>
+          <a:ln w="12700">
+            <a:solidFill>
+              <a:srgbClr val="E2E6EA"/>
+            </a:solidFill>
+            <a:prstDash val="solid"/>
+          </a:ln>
+          <a:effectLst>
+            <a:outerShdw sx="100000" sy="100000" kx="0" ky="0" algn="bl" rotWithShape="0" blurRad="127000" dist="38100" dir="5400000">
+              <a:srgbClr val="1F2937">
+                <a:alpha val="18000"/>
+              </a:srgbClr>
+            </a:outerShdw>
+          </a:effectLst>
         </p:spPr>
       </p:sp>
       <p:pic>
         <p:nvPicPr>
-          <p:cNvPr id="11" name="Image 1" descr="preencoded.png">    </p:cNvPr>
+          <p:cNvPr id="8" name="Image 1" descr="Project risk register for Riyadh Hospital Project 3">    </p:cNvPr>
           <p:cNvPicPr>
             <a:picLocks noChangeAspect="1"/>
           </p:cNvPicPr>
@@ -5972,8 +5919,8 @@
         </p:blipFill>
         <p:spPr>
           <a:xfrm>
-            <a:off x="4512564" y="3456432"/>
-            <a:ext cx="402336" cy="402336"/>
+            <a:off x="6172200" y="2698080"/>
+            <a:ext cx="5257800" cy="2742001"/>
           </a:xfrm>
           <a:prstGeom prst="rect">
             <a:avLst/>
@@ -5982,382 +5929,46 @@
       </p:pic>
       <p:sp>
         <p:nvSpPr>
-          <p:cNvPr id="12" name="Text 8"/>
-          <p:cNvSpPr/>
-          <p:nvPr/>
-        </p:nvSpPr>
-        <p:spPr>
-          <a:xfrm>
-            <a:off x="3575304" y="4206240"/>
-            <a:ext cx="2276856" cy="502920"/>
-          </a:xfrm>
-          <a:prstGeom prst="rect">
-            <a:avLst/>
-          </a:prstGeom>
-          <a:noFill/>
-          <a:ln/>
-        </p:spPr>
-        <p:txBody>
-          <a:bodyPr wrap="square" lIns="0" tIns="0" rIns="0" bIns="0" rtlCol="0" anchor="ctr"/>
-          <a:lstStyle/>
-          <a:p>
-            <a:pPr algn="ctr" indent="0" marL="0">
-              <a:buNone/>
-            </a:pPr>
-            <a:r>
-              <a:rPr lang="en-US" sz="1500" b="1" dirty="0">
-                <a:solidFill>
-                  <a:srgbClr val="132A46"/>
-                </a:solidFill>
-                <a:latin typeface="Calibri" pitchFamily="34" charset="0"/>
-                <a:ea typeface="Calibri" pitchFamily="34" charset="-122"/>
-                <a:cs typeface="Calibri" pitchFamily="34" charset="-120"/>
-              </a:rPr>
-              <a:t>AI Workflows</a:t>
-            </a:r>
-            <a:endParaRPr lang="en-US" sz="1500" dirty="0"/>
-          </a:p>
-        </p:txBody>
-      </p:sp>
-      <p:sp>
-        <p:nvSpPr>
-          <p:cNvPr id="13" name="Text 9"/>
-          <p:cNvSpPr/>
-          <p:nvPr/>
-        </p:nvSpPr>
-        <p:spPr>
-          <a:xfrm>
-            <a:off x="3611880" y="4709160"/>
-            <a:ext cx="2203704" cy="914400"/>
-          </a:xfrm>
-          <a:prstGeom prst="rect">
-            <a:avLst/>
-          </a:prstGeom>
-          <a:noFill/>
-          <a:ln/>
-        </p:spPr>
-        <p:txBody>
-          <a:bodyPr wrap="square" lIns="0" tIns="0" rIns="0" bIns="0" rtlCol="0" anchor="ctr"/>
-          <a:lstStyle/>
-          <a:p>
-            <a:pPr algn="ctr" indent="0" marL="0">
-              <a:lnSpc>
-                <a:spcPct val="125000"/>
-              </a:lnSpc>
-              <a:buNone/>
-            </a:pPr>
-            <a:r>
-              <a:rPr lang="en-US" sz="1150" dirty="0">
-                <a:solidFill>
-                  <a:srgbClr val="5B6B79"/>
-                </a:solidFill>
-                <a:latin typeface="Calibri" pitchFamily="34" charset="0"/>
-                <a:ea typeface="Calibri" pitchFamily="34" charset="-122"/>
-                <a:cs typeface="Calibri" pitchFamily="34" charset="-120"/>
-              </a:rPr>
-              <a:t>Six workflows that read the record and produce a decision-ready output.</a:t>
-            </a:r>
-            <a:endParaRPr lang="en-US" sz="1150" dirty="0"/>
-          </a:p>
-        </p:txBody>
-      </p:sp>
-      <p:sp>
-        <p:nvSpPr>
-          <p:cNvPr id="14" name="Shape 10"/>
-          <p:cNvSpPr/>
-          <p:nvPr/>
-        </p:nvSpPr>
-        <p:spPr>
-          <a:xfrm>
-            <a:off x="6272784" y="2971800"/>
-            <a:ext cx="2606040" cy="2743200"/>
-          </a:xfrm>
-          <a:prstGeom prst="roundRect">
-            <a:avLst>
-              <a:gd name="adj" fmla="val 4211"/>
-            </a:avLst>
-          </a:prstGeom>
-          <a:solidFill>
-            <a:srgbClr val="F4F6F8"/>
-          </a:solidFill>
-          <a:ln/>
-        </p:spPr>
-      </p:sp>
-      <p:sp>
-        <p:nvSpPr>
-          <p:cNvPr id="15" name="Shape 11"/>
-          <p:cNvSpPr/>
-          <p:nvPr/>
-        </p:nvSpPr>
-        <p:spPr>
-          <a:xfrm>
-            <a:off x="7210044" y="3291840"/>
-            <a:ext cx="731520" cy="731520"/>
-          </a:xfrm>
-          <a:prstGeom prst="ellipse">
-            <a:avLst/>
-          </a:prstGeom>
-          <a:solidFill>
-            <a:srgbClr val="132A46"/>
-          </a:solidFill>
-          <a:ln/>
-        </p:spPr>
-      </p:sp>
-      <p:pic>
-        <p:nvPicPr>
-          <p:cNvPr id="16" name="Image 2" descr="preencoded.png">    </p:cNvPr>
-          <p:cNvPicPr>
-            <a:picLocks noChangeAspect="1"/>
-          </p:cNvPicPr>
-          <p:nvPr/>
-        </p:nvPicPr>
-        <p:blipFill>
-          <a:blip r:embed="rId3"/>
-          <a:stretch>
-            <a:fillRect/>
-          </a:stretch>
-        </p:blipFill>
-        <p:spPr>
-          <a:xfrm>
-            <a:off x="7374636" y="3456432"/>
-            <a:ext cx="402336" cy="402336"/>
-          </a:xfrm>
-          <a:prstGeom prst="rect">
-            <a:avLst/>
-          </a:prstGeom>
-        </p:spPr>
-      </p:pic>
-      <p:sp>
-        <p:nvSpPr>
-          <p:cNvPr id="17" name="Text 12"/>
-          <p:cNvSpPr/>
-          <p:nvPr/>
-        </p:nvSpPr>
-        <p:spPr>
-          <a:xfrm>
-            <a:off x="6437376" y="4206240"/>
-            <a:ext cx="2276856" cy="502920"/>
-          </a:xfrm>
-          <a:prstGeom prst="rect">
-            <a:avLst/>
-          </a:prstGeom>
-          <a:noFill/>
-          <a:ln/>
-        </p:spPr>
-        <p:txBody>
-          <a:bodyPr wrap="square" lIns="0" tIns="0" rIns="0" bIns="0" rtlCol="0" anchor="ctr"/>
-          <a:lstStyle/>
-          <a:p>
-            <a:pPr algn="ctr" indent="0" marL="0">
-              <a:buNone/>
-            </a:pPr>
-            <a:r>
-              <a:rPr lang="en-US" sz="1500" b="1" dirty="0">
-                <a:solidFill>
-                  <a:srgbClr val="132A46"/>
-                </a:solidFill>
-                <a:latin typeface="Calibri" pitchFamily="34" charset="0"/>
-                <a:ea typeface="Calibri" pitchFamily="34" charset="-122"/>
-                <a:cs typeface="Calibri" pitchFamily="34" charset="-120"/>
-              </a:rPr>
-              <a:t>Enterprise Memory</a:t>
-            </a:r>
-            <a:endParaRPr lang="en-US" sz="1500" dirty="0"/>
-          </a:p>
-        </p:txBody>
-      </p:sp>
-      <p:sp>
-        <p:nvSpPr>
-          <p:cNvPr id="18" name="Text 13"/>
-          <p:cNvSpPr/>
-          <p:nvPr/>
-        </p:nvSpPr>
-        <p:spPr>
-          <a:xfrm>
-            <a:off x="6473952" y="4709160"/>
-            <a:ext cx="2203704" cy="914400"/>
-          </a:xfrm>
-          <a:prstGeom prst="rect">
-            <a:avLst/>
-          </a:prstGeom>
-          <a:noFill/>
-          <a:ln/>
-        </p:spPr>
-        <p:txBody>
-          <a:bodyPr wrap="square" lIns="0" tIns="0" rIns="0" bIns="0" rtlCol="0" anchor="ctr"/>
-          <a:lstStyle/>
-          <a:p>
-            <a:pPr algn="ctr" indent="0" marL="0">
-              <a:lnSpc>
-                <a:spcPct val="125000"/>
-              </a:lnSpc>
-              <a:buNone/>
-            </a:pPr>
-            <a:r>
-              <a:rPr lang="en-US" sz="1150" dirty="0">
-                <a:solidFill>
-                  <a:srgbClr val="5B6B79"/>
-                </a:solidFill>
-                <a:latin typeface="Calibri" pitchFamily="34" charset="0"/>
-                <a:ea typeface="Calibri" pitchFamily="34" charset="-122"/>
-                <a:cs typeface="Calibri" pitchFamily="34" charset="-120"/>
-              </a:rPr>
-              <a:t>A searchable memory of decisions and risk that grows on its own.</a:t>
-            </a:r>
-            <a:endParaRPr lang="en-US" sz="1150" dirty="0"/>
-          </a:p>
-        </p:txBody>
-      </p:sp>
-      <p:sp>
-        <p:nvSpPr>
-          <p:cNvPr id="19" name="Shape 14"/>
-          <p:cNvSpPr/>
-          <p:nvPr/>
-        </p:nvSpPr>
-        <p:spPr>
-          <a:xfrm>
-            <a:off x="9134856" y="2971800"/>
-            <a:ext cx="2606040" cy="2743200"/>
-          </a:xfrm>
-          <a:prstGeom prst="roundRect">
-            <a:avLst>
-              <a:gd name="adj" fmla="val 4211"/>
-            </a:avLst>
-          </a:prstGeom>
-          <a:solidFill>
-            <a:srgbClr val="F4F6F8"/>
-          </a:solidFill>
-          <a:ln/>
-        </p:spPr>
-      </p:sp>
-      <p:sp>
-        <p:nvSpPr>
-          <p:cNvPr id="20" name="Shape 15"/>
-          <p:cNvSpPr/>
-          <p:nvPr/>
-        </p:nvSpPr>
-        <p:spPr>
-          <a:xfrm>
-            <a:off x="10072116" y="3291840"/>
-            <a:ext cx="731520" cy="731520"/>
-          </a:xfrm>
-          <a:prstGeom prst="ellipse">
-            <a:avLst/>
-          </a:prstGeom>
-          <a:solidFill>
-            <a:srgbClr val="132A46"/>
-          </a:solidFill>
-          <a:ln/>
-        </p:spPr>
-      </p:sp>
-      <p:pic>
-        <p:nvPicPr>
-          <p:cNvPr id="21" name="Image 3" descr="preencoded.png">    </p:cNvPr>
-          <p:cNvPicPr>
-            <a:picLocks noChangeAspect="1"/>
-          </p:cNvPicPr>
-          <p:nvPr/>
-        </p:nvPicPr>
-        <p:blipFill>
-          <a:blip r:embed="rId4"/>
-          <a:stretch>
-            <a:fillRect/>
-          </a:stretch>
-        </p:blipFill>
-        <p:spPr>
-          <a:xfrm>
-            <a:off x="10236708" y="3456432"/>
-            <a:ext cx="402336" cy="402336"/>
-          </a:xfrm>
-          <a:prstGeom prst="rect">
-            <a:avLst/>
-          </a:prstGeom>
-        </p:spPr>
-      </p:pic>
-      <p:sp>
-        <p:nvSpPr>
-          <p:cNvPr id="22" name="Text 16"/>
-          <p:cNvSpPr/>
-          <p:nvPr/>
-        </p:nvSpPr>
-        <p:spPr>
-          <a:xfrm>
-            <a:off x="9299448" y="4206240"/>
-            <a:ext cx="2276856" cy="502920"/>
-          </a:xfrm>
-          <a:prstGeom prst="rect">
-            <a:avLst/>
-          </a:prstGeom>
-          <a:noFill/>
-          <a:ln/>
-        </p:spPr>
-        <p:txBody>
-          <a:bodyPr wrap="square" lIns="0" tIns="0" rIns="0" bIns="0" rtlCol="0" anchor="ctr"/>
-          <a:lstStyle/>
-          <a:p>
-            <a:pPr algn="ctr" indent="0" marL="0">
-              <a:buNone/>
-            </a:pPr>
-            <a:r>
-              <a:rPr lang="en-US" sz="1500" b="1" dirty="0">
-                <a:solidFill>
-                  <a:srgbClr val="132A46"/>
-                </a:solidFill>
-                <a:latin typeface="Calibri" pitchFamily="34" charset="0"/>
-                <a:ea typeface="Calibri" pitchFamily="34" charset="-122"/>
-                <a:cs typeface="Calibri" pitchFamily="34" charset="-120"/>
-              </a:rPr>
-              <a:t>Governance</a:t>
-            </a:r>
-            <a:endParaRPr lang="en-US" sz="1500" dirty="0"/>
-          </a:p>
-        </p:txBody>
-      </p:sp>
-      <p:sp>
-        <p:nvSpPr>
-          <p:cNvPr id="23" name="Text 17"/>
-          <p:cNvSpPr/>
-          <p:nvPr/>
-        </p:nvSpPr>
-        <p:spPr>
-          <a:xfrm>
-            <a:off x="9336024" y="4709160"/>
-            <a:ext cx="2203704" cy="914400"/>
-          </a:xfrm>
-          <a:prstGeom prst="rect">
-            <a:avLst/>
-          </a:prstGeom>
-          <a:noFill/>
-          <a:ln/>
-        </p:spPr>
-        <p:txBody>
-          <a:bodyPr wrap="square" lIns="0" tIns="0" rIns="0" bIns="0" rtlCol="0" anchor="ctr"/>
-          <a:lstStyle/>
-          <a:p>
-            <a:pPr algn="ctr" indent="0" marL="0">
-              <a:lnSpc>
-                <a:spcPct val="125000"/>
-              </a:lnSpc>
-              <a:buNone/>
-            </a:pPr>
-            <a:r>
-              <a:rPr lang="en-US" sz="1150" dirty="0">
-                <a:solidFill>
-                  <a:srgbClr val="5B6B79"/>
-                </a:solidFill>
-                <a:latin typeface="Calibri" pitchFamily="34" charset="0"/>
-                <a:ea typeface="Calibri" pitchFamily="34" charset="-122"/>
-                <a:cs typeface="Calibri" pitchFamily="34" charset="-120"/>
-              </a:rPr>
-              <a:t>Role-based access, a full audit trail, and human approval on risk.</a:t>
-            </a:r>
-            <a:endParaRPr lang="en-US" sz="1150" dirty="0"/>
-          </a:p>
-        </p:txBody>
-      </p:sp>
-      <p:sp>
-        <p:nvSpPr>
-          <p:cNvPr id="24" name="Text 18"/>
+          <p:cNvPr id="9" name="Text 5"/>
+          <p:cNvSpPr/>
+          <p:nvPr/>
+        </p:nvSpPr>
+        <p:spPr>
+          <a:xfrm>
+            <a:off x="6172200" y="5549808"/>
+            <a:ext cx="5257800" cy="320040"/>
+          </a:xfrm>
+          <a:prstGeom prst="rect">
+            <a:avLst/>
+          </a:prstGeom>
+          <a:noFill/>
+          <a:ln/>
+        </p:spPr>
+        <p:txBody>
+          <a:bodyPr wrap="square" lIns="0" tIns="0" rIns="0" bIns="0" rtlCol="0" anchor="ctr"/>
+          <a:lstStyle/>
+          <a:p>
+            <a:pPr indent="0" marL="0">
+              <a:buNone/>
+            </a:pPr>
+            <a:r>
+              <a:rPr lang="en-US" sz="1100" i="1" dirty="0">
+                <a:solidFill>
+                  <a:srgbClr val="8A97A3"/>
+                </a:solidFill>
+                <a:latin typeface="Calibri" pitchFamily="34" charset="0"/>
+                <a:ea typeface="Calibri" pitchFamily="34" charset="-122"/>
+                <a:cs typeface="Calibri" pitchFamily="34" charset="-120"/>
+              </a:rPr>
+              <a:t>Project workspace — risk register for a live project</a:t>
+            </a:r>
+            <a:endParaRPr lang="en-US" sz="1100" dirty="0"/>
+          </a:p>
+        </p:txBody>
+      </p:sp>
+      <p:sp>
+        <p:nvSpPr>
+          <p:cNvPr id="10" name="Text 6"/>
           <p:cNvSpPr/>
           <p:nvPr/>
         </p:nvSpPr>
@@ -6376,7 +5987,7 @@
           <a:bodyPr wrap="square" lIns="0" tIns="0" rIns="0" bIns="0" rtlCol="0" anchor="ctr"/>
           <a:lstStyle/>
           <a:p>
-            <a:pPr algn="l" indent="0" marL="0">
+            <a:pPr indent="0" marL="0">
               <a:buNone/>
             </a:pPr>
             <a:r>
@@ -6396,7 +6007,7 @@
       </p:sp>
       <p:sp>
         <p:nvSpPr>
-          <p:cNvPr id="25" name="Text 19"/>
+          <p:cNvPr id="11" name="Text 7"/>
           <p:cNvSpPr/>
           <p:nvPr/>
         </p:nvSpPr>
@@ -7887,7 +7498,7 @@
           <a:bodyPr wrap="square" lIns="0" tIns="0" rIns="0" bIns="0" rtlCol="0" anchor="ctr"/>
           <a:lstStyle/>
           <a:p>
-            <a:pPr algn="l" indent="0" marL="0">
+            <a:pPr indent="0" marL="0">
               <a:buNone/>
             </a:pPr>
             <a:r>
@@ -8786,7 +8397,7 @@
           <a:bodyPr wrap="square" lIns="0" tIns="0" rIns="0" bIns="0" rtlCol="0" anchor="ctr"/>
           <a:lstStyle/>
           <a:p>
-            <a:pPr algn="l" indent="0" marL="0">
+            <a:pPr indent="0" marL="0">
               <a:buNone/>
             </a:pPr>
             <a:r>
@@ -9449,7 +9060,7 @@
           <a:bodyPr wrap="square" lIns="0" tIns="0" rIns="0" bIns="0" rtlCol="0" anchor="ctr"/>
           <a:lstStyle/>
           <a:p>
-            <a:pPr algn="l" indent="0" marL="0">
+            <a:pPr indent="0" marL="0">
               <a:buNone/>
             </a:pPr>
             <a:r>
@@ -9585,8 +9196,8 @@
         </p:nvSpPr>
         <p:spPr>
           <a:xfrm>
-            <a:off x="548640" y="1508760"/>
-            <a:ext cx="5943600" cy="2651760"/>
+            <a:off x="548640" y="1417320"/>
+            <a:ext cx="4206240" cy="1737360"/>
           </a:xfrm>
           <a:prstGeom prst="rect">
             <a:avLst/>
@@ -9605,7 +9216,7 @@
               <a:buNone/>
             </a:pPr>
             <a:r>
-              <a:rPr lang="en-US" sz="1500" dirty="0">
+              <a:rPr lang="en-US" sz="1450" dirty="0">
                 <a:solidFill>
                   <a:srgbClr val="5B6B79"/>
                 </a:solidFill>
@@ -9613,9 +9224,9 @@
                 <a:ea typeface="Calibri" pitchFamily="34" charset="-122"/>
                 <a:cs typeface="Calibri" pitchFamily="34" charset="-120"/>
               </a:rPr>
-              <a:t>The copilot answers management's questions from the project's own records — risks, issues, decisions, milestones — and cites every source it used. Ask about a named project and retrieval is scoped to it, so one project's records are never presented as another's. When there is no evidence, it says so instead of inventing an answer.</a:t>
-            </a:r>
-            <a:endParaRPr lang="en-US" sz="1500" dirty="0"/>
+              <a:t>Ask about a named project and retrieval is scoped to it, so one project's records are never presented as another's. Every answer cites its sources, and when there is no evidence, it says so instead of inventing one.</a:t>
+            </a:r>
+            <a:endParaRPr lang="en-US" sz="1450" dirty="0"/>
           </a:p>
         </p:txBody>
       </p:sp>
@@ -9627,7 +9238,7 @@
         </p:nvSpPr>
         <p:spPr>
           <a:xfrm>
-            <a:off x="548640" y="4297680"/>
+            <a:off x="548640" y="3383280"/>
             <a:ext cx="1005840" cy="777240"/>
           </a:xfrm>
           <a:prstGeom prst="rect">
@@ -9666,247 +9277,8 @@
         </p:nvSpPr>
         <p:spPr>
           <a:xfrm>
-            <a:off x="1600200" y="4407408"/>
-            <a:ext cx="4754880" cy="594360"/>
-          </a:xfrm>
-          <a:prstGeom prst="rect">
-            <a:avLst/>
-          </a:prstGeom>
-          <a:noFill/>
-          <a:ln/>
-        </p:spPr>
-        <p:txBody>
-          <a:bodyPr wrap="square" lIns="0" tIns="0" rIns="0" bIns="0" rtlCol="0" anchor="ctr"/>
-          <a:lstStyle/>
-          <a:p>
-            <a:pPr indent="0" marL="0">
-              <a:buNone/>
-            </a:pPr>
-            <a:r>
-              <a:rPr lang="en-US" sz="1300" dirty="0">
-                <a:solidFill>
-                  <a:srgbClr val="132A46"/>
-                </a:solidFill>
-                <a:latin typeface="Calibri" pitchFamily="34" charset="0"/>
-                <a:ea typeface="Calibri" pitchFamily="34" charset="-122"/>
-                <a:cs typeface="Calibri" pitchFamily="34" charset="-120"/>
-              </a:rPr>
-              <a:t>answers without a cited source</a:t>
-            </a:r>
-            <a:endParaRPr lang="en-US" sz="1300" dirty="0"/>
-          </a:p>
-        </p:txBody>
-      </p:sp>
-      <p:sp>
-        <p:nvSpPr>
-          <p:cNvPr id="6" name="Text 4"/>
-          <p:cNvSpPr/>
-          <p:nvPr/>
-        </p:nvSpPr>
-        <p:spPr>
-          <a:xfrm>
-            <a:off x="548640" y="5166360"/>
-            <a:ext cx="1005840" cy="777240"/>
-          </a:xfrm>
-          <a:prstGeom prst="rect">
-            <a:avLst/>
-          </a:prstGeom>
-          <a:noFill/>
-          <a:ln/>
-        </p:spPr>
-        <p:txBody>
-          <a:bodyPr wrap="square" lIns="0" tIns="0" rIns="0" bIns="0" rtlCol="0" anchor="ctr"/>
-          <a:lstStyle/>
-          <a:p>
-            <a:pPr indent="0" marL="0">
-              <a:buNone/>
-            </a:pPr>
-            <a:r>
-              <a:rPr lang="en-US" sz="4000" b="1" dirty="0">
-                <a:solidFill>
-                  <a:srgbClr val="E8622C"/>
-                </a:solidFill>
-                <a:latin typeface="Calibri" pitchFamily="34" charset="0"/>
-                <a:ea typeface="Calibri" pitchFamily="34" charset="-122"/>
-                <a:cs typeface="Calibri" pitchFamily="34" charset="-120"/>
-              </a:rPr>
-              <a:t>2</a:t>
-            </a:r>
-            <a:endParaRPr lang="en-US" sz="4000" dirty="0"/>
-          </a:p>
-        </p:txBody>
-      </p:sp>
-      <p:sp>
-        <p:nvSpPr>
-          <p:cNvPr id="7" name="Text 5"/>
-          <p:cNvSpPr/>
-          <p:nvPr/>
-        </p:nvSpPr>
-        <p:spPr>
-          <a:xfrm>
-            <a:off x="1600200" y="5276088"/>
-            <a:ext cx="4754880" cy="594360"/>
-          </a:xfrm>
-          <a:prstGeom prst="rect">
-            <a:avLst/>
-          </a:prstGeom>
-          <a:noFill/>
-          <a:ln/>
-        </p:spPr>
-        <p:txBody>
-          <a:bodyPr wrap="square" lIns="0" tIns="0" rIns="0" bIns="0" rtlCol="0" anchor="ctr"/>
-          <a:lstStyle/>
-          <a:p>
-            <a:pPr indent="0" marL="0">
-              <a:buNone/>
-            </a:pPr>
-            <a:r>
-              <a:rPr lang="en-US" sz="1300" dirty="0">
-                <a:solidFill>
-                  <a:srgbClr val="132A46"/>
-                </a:solidFill>
-                <a:latin typeface="Calibri" pitchFamily="34" charset="0"/>
-                <a:ea typeface="Calibri" pitchFamily="34" charset="-122"/>
-                <a:cs typeface="Calibri" pitchFamily="34" charset="-120"/>
-              </a:rPr>
-              <a:t>languages — replies in the language asked</a:t>
-            </a:r>
-            <a:endParaRPr lang="en-US" sz="1300" dirty="0"/>
-          </a:p>
-        </p:txBody>
-      </p:sp>
-      <p:sp>
-        <p:nvSpPr>
-          <p:cNvPr id="8" name="Shape 6"/>
-          <p:cNvSpPr/>
-          <p:nvPr/>
-        </p:nvSpPr>
-        <p:spPr>
-          <a:xfrm>
-            <a:off x="7040880" y="1508760"/>
-            <a:ext cx="4617720" cy="4434840"/>
-          </a:xfrm>
-          <a:prstGeom prst="roundRect">
-            <a:avLst>
-              <a:gd name="adj" fmla="val 2474"/>
-            </a:avLst>
-          </a:prstGeom>
-          <a:solidFill>
-            <a:srgbClr val="132A46"/>
-          </a:solidFill>
-          <a:ln/>
-        </p:spPr>
-      </p:sp>
-      <p:sp>
-        <p:nvSpPr>
-          <p:cNvPr id="9" name="Text 7"/>
-          <p:cNvSpPr/>
-          <p:nvPr/>
-        </p:nvSpPr>
-        <p:spPr>
-          <a:xfrm>
-            <a:off x="7360920" y="1783080"/>
-            <a:ext cx="3977640" cy="320040"/>
-          </a:xfrm>
-          <a:prstGeom prst="rect">
-            <a:avLst/>
-          </a:prstGeom>
-          <a:noFill/>
-          <a:ln/>
-        </p:spPr>
-        <p:txBody>
-          <a:bodyPr wrap="square" lIns="0" tIns="0" rIns="0" bIns="0" rtlCol="0" anchor="ctr"/>
-          <a:lstStyle/>
-          <a:p>
-            <a:pPr indent="0" marL="0">
-              <a:buNone/>
-            </a:pPr>
-            <a:r>
-              <a:rPr lang="en-US" sz="1100" b="1" spc="200" kern="0" dirty="0">
-                <a:solidFill>
-                  <a:srgbClr val="8A97A3"/>
-                </a:solidFill>
-                <a:latin typeface="Calibri" pitchFamily="34" charset="0"/>
-                <a:ea typeface="Calibri" pitchFamily="34" charset="-122"/>
-                <a:cs typeface="Calibri" pitchFamily="34" charset="-120"/>
-              </a:rPr>
-              <a:t>COPILOT</a:t>
-            </a:r>
-            <a:endParaRPr lang="en-US" sz="1100" dirty="0"/>
-          </a:p>
-        </p:txBody>
-      </p:sp>
-      <p:sp>
-        <p:nvSpPr>
-          <p:cNvPr id="10" name="Shape 8"/>
-          <p:cNvSpPr/>
-          <p:nvPr/>
-        </p:nvSpPr>
-        <p:spPr>
-          <a:xfrm>
-            <a:off x="7360920" y="2240280"/>
-            <a:ext cx="3794760" cy="548640"/>
-          </a:xfrm>
-          <a:prstGeom prst="roundRect">
-            <a:avLst>
-              <a:gd name="adj" fmla="val 16667"/>
-            </a:avLst>
-          </a:prstGeom>
-          <a:solidFill>
-            <a:srgbClr val="1E3A5C"/>
-          </a:solidFill>
-          <a:ln/>
-        </p:spPr>
-      </p:sp>
-      <p:sp>
-        <p:nvSpPr>
-          <p:cNvPr id="11" name="Text 9"/>
-          <p:cNvSpPr/>
-          <p:nvPr/>
-        </p:nvSpPr>
-        <p:spPr>
-          <a:xfrm>
-            <a:off x="7543800" y="2240280"/>
-            <a:ext cx="3429000" cy="548640"/>
-          </a:xfrm>
-          <a:prstGeom prst="rect">
-            <a:avLst/>
-          </a:prstGeom>
-          <a:noFill/>
-          <a:ln/>
-        </p:spPr>
-        <p:txBody>
-          <a:bodyPr wrap="square" lIns="0" tIns="0" rIns="0" bIns="0" rtlCol="0" anchor="ctr"/>
-          <a:lstStyle/>
-          <a:p>
-            <a:pPr indent="0" marL="0">
-              <a:buNone/>
-            </a:pPr>
-            <a:r>
-              <a:rPr lang="en-US" sz="1150" i="1" dirty="0">
-                <a:solidFill>
-                  <a:srgbClr val="FFFFFF"/>
-                </a:solidFill>
-                <a:latin typeface="Calibri" pitchFamily="34" charset="0"/>
-                <a:ea typeface="Calibri" pitchFamily="34" charset="-122"/>
-                <a:cs typeface="Calibri" pitchFamily="34" charset="-120"/>
-              </a:rPr>
-              <a:t>"What are the risks on Riyadh Hospital Project 3?"</a:t>
-            </a:r>
-            <a:endParaRPr lang="en-US" sz="1150" dirty="0"/>
-          </a:p>
-        </p:txBody>
-      </p:sp>
-      <p:sp>
-        <p:nvSpPr>
-          <p:cNvPr id="12" name="Text 10"/>
-          <p:cNvSpPr/>
-          <p:nvPr/>
-        </p:nvSpPr>
-        <p:spPr>
-          <a:xfrm>
-            <a:off x="7360920" y="3017520"/>
-            <a:ext cx="3977640" cy="1463040"/>
+            <a:off x="1600200" y="3493008"/>
+            <a:ext cx="3017520" cy="685800"/>
           </a:xfrm>
           <a:prstGeom prst="rect">
             <a:avLst/>
@@ -9922,206 +9294,165 @@
               <a:lnSpc>
                 <a:spcPct val="120000"/>
               </a:lnSpc>
-              <a:spcAft>
-                <a:spcPts val="600"/>
-              </a:spcAft>
-              <a:buNone/>
-            </a:pPr>
-            <a:r>
-              <a:rPr lang="en-US" sz="1250" b="1" dirty="0">
-                <a:solidFill>
-                  <a:srgbClr val="FFFFFF"/>
-                </a:solidFill>
-                <a:latin typeface="Calibri" pitchFamily="34" charset="0"/>
-                <a:ea typeface="Calibri" pitchFamily="34" charset="-122"/>
-                <a:cs typeface="Calibri" pitchFamily="34" charset="-120"/>
-              </a:rPr>
-              <a:t>6 open risks found, ranked by severity:</a:t>
-            </a:r>
-            <a:endParaRPr lang="en-US" sz="1250" dirty="0"/>
-          </a:p>
-          <a:p>
-            <a:pPr marL="177800" indent="-177800">
+              <a:buNone/>
+            </a:pPr>
+            <a:r>
+              <a:rPr lang="en-US" sz="1300" dirty="0">
+                <a:solidFill>
+                  <a:srgbClr val="132A46"/>
+                </a:solidFill>
+                <a:latin typeface="Calibri" pitchFamily="34" charset="0"/>
+                <a:ea typeface="Calibri" pitchFamily="34" charset="-122"/>
+                <a:cs typeface="Calibri" pitchFamily="34" charset="-120"/>
+              </a:rPr>
+              <a:t>answers without a cited source</a:t>
+            </a:r>
+            <a:endParaRPr lang="en-US" sz="1300" dirty="0"/>
+          </a:p>
+        </p:txBody>
+      </p:sp>
+      <p:sp>
+        <p:nvSpPr>
+          <p:cNvPr id="6" name="Text 4"/>
+          <p:cNvSpPr/>
+          <p:nvPr/>
+        </p:nvSpPr>
+        <p:spPr>
+          <a:xfrm>
+            <a:off x="548640" y="4434840"/>
+            <a:ext cx="1005840" cy="777240"/>
+          </a:xfrm>
+          <a:prstGeom prst="rect">
+            <a:avLst/>
+          </a:prstGeom>
+          <a:noFill/>
+          <a:ln/>
+        </p:spPr>
+        <p:txBody>
+          <a:bodyPr wrap="square" lIns="0" tIns="0" rIns="0" bIns="0" rtlCol="0" anchor="ctr"/>
+          <a:lstStyle/>
+          <a:p>
+            <a:pPr indent="0" marL="0">
+              <a:buNone/>
+            </a:pPr>
+            <a:r>
+              <a:rPr lang="en-US" sz="4000" b="1" dirty="0">
+                <a:solidFill>
+                  <a:srgbClr val="E8622C"/>
+                </a:solidFill>
+                <a:latin typeface="Calibri" pitchFamily="34" charset="0"/>
+                <a:ea typeface="Calibri" pitchFamily="34" charset="-122"/>
+                <a:cs typeface="Calibri" pitchFamily="34" charset="-120"/>
+              </a:rPr>
+              <a:t>2</a:t>
+            </a:r>
+            <a:endParaRPr lang="en-US" sz="4000" dirty="0"/>
+          </a:p>
+        </p:txBody>
+      </p:sp>
+      <p:sp>
+        <p:nvSpPr>
+          <p:cNvPr id="7" name="Text 5"/>
+          <p:cNvSpPr/>
+          <p:nvPr/>
+        </p:nvSpPr>
+        <p:spPr>
+          <a:xfrm>
+            <a:off x="1600200" y="4544568"/>
+            <a:ext cx="3017520" cy="685800"/>
+          </a:xfrm>
+          <a:prstGeom prst="rect">
+            <a:avLst/>
+          </a:prstGeom>
+          <a:noFill/>
+          <a:ln/>
+        </p:spPr>
+        <p:txBody>
+          <a:bodyPr wrap="square" lIns="0" tIns="0" rIns="0" bIns="0" rtlCol="0" anchor="ctr"/>
+          <a:lstStyle/>
+          <a:p>
+            <a:pPr indent="0" marL="0">
               <a:lnSpc>
                 <a:spcPct val="120000"/>
               </a:lnSpc>
-              <a:spcAft>
-                <a:spcPts val="600"/>
-              </a:spcAft>
-              <a:buSzPct val="100000"/>
-              <a:buChar char="•"/>
-            </a:pPr>
-            <a:r>
-              <a:rPr lang="en-US" sz="1100" dirty="0">
-                <a:solidFill>
-                  <a:srgbClr val="C7D2DE"/>
-                </a:solidFill>
-                <a:latin typeface="Calibri" pitchFamily="34" charset="0"/>
-                <a:ea typeface="Calibri" pitchFamily="34" charset="-122"/>
-                <a:cs typeface="Calibri" pitchFamily="34" charset="-120"/>
-              </a:rPr>
-              <a:t>Dewatering pump capacity below inflow rate — High</a:t>
-            </a:r>
-            <a:endParaRPr lang="en-US" sz="1250" dirty="0"/>
-          </a:p>
-          <a:p>
-            <a:pPr marL="177800" indent="-177800">
-              <a:lnSpc>
-                <a:spcPct val="120000"/>
-              </a:lnSpc>
-              <a:spcAft>
-                <a:spcPts val="600"/>
-              </a:spcAft>
-              <a:buSzPct val="100000"/>
-              <a:buChar char="•"/>
-            </a:pPr>
-            <a:r>
-              <a:rPr lang="en-US" sz="1100" dirty="0">
-                <a:solidFill>
-                  <a:srgbClr val="C7D2DE"/>
-                </a:solidFill>
-                <a:latin typeface="Calibri" pitchFamily="34" charset="0"/>
-                <a:ea typeface="Calibri" pitchFamily="34" charset="-122"/>
-                <a:cs typeface="Calibri" pitchFamily="34" charset="-120"/>
-              </a:rPr>
-              <a:t>Rebar submittal delay for Level 3 slab — High</a:t>
-            </a:r>
-            <a:endParaRPr lang="en-US" sz="1250" dirty="0"/>
-          </a:p>
-          <a:p>
-            <a:pPr marL="177800" indent="-177800">
-              <a:lnSpc>
-                <a:spcPct val="120000"/>
-              </a:lnSpc>
-              <a:spcAft>
-                <a:spcPts val="600"/>
-              </a:spcAft>
-              <a:buSzPct val="100000"/>
-              <a:buChar char="•"/>
-            </a:pPr>
-            <a:r>
-              <a:rPr lang="en-US" sz="1100" dirty="0">
-                <a:solidFill>
-                  <a:srgbClr val="C7D2DE"/>
-                </a:solidFill>
-                <a:latin typeface="Calibri" pitchFamily="34" charset="0"/>
-                <a:ea typeface="Calibri" pitchFamily="34" charset="-122"/>
-                <a:cs typeface="Calibri" pitchFamily="34" charset="-120"/>
-              </a:rPr>
-              <a:t>Site access restricted after 6pm — Medium</a:t>
-            </a:r>
-            <a:endParaRPr lang="en-US" sz="1250" dirty="0"/>
-          </a:p>
-        </p:txBody>
-      </p:sp>
-      <p:sp>
-        <p:nvSpPr>
-          <p:cNvPr id="13" name="Shape 11"/>
-          <p:cNvSpPr/>
-          <p:nvPr/>
-        </p:nvSpPr>
-        <p:spPr>
-          <a:xfrm>
-            <a:off x="7360920" y="4709160"/>
-            <a:ext cx="3977640" cy="914400"/>
+              <a:buNone/>
+            </a:pPr>
+            <a:r>
+              <a:rPr lang="en-US" sz="1300" dirty="0">
+                <a:solidFill>
+                  <a:srgbClr val="132A46"/>
+                </a:solidFill>
+                <a:latin typeface="Calibri" pitchFamily="34" charset="0"/>
+                <a:ea typeface="Calibri" pitchFamily="34" charset="-122"/>
+                <a:cs typeface="Calibri" pitchFamily="34" charset="-120"/>
+              </a:rPr>
+              <a:t>languages — replies in the language asked</a:t>
+            </a:r>
+            <a:endParaRPr lang="en-US" sz="1300" dirty="0"/>
+          </a:p>
+        </p:txBody>
+      </p:sp>
+      <p:sp>
+        <p:nvSpPr>
+          <p:cNvPr id="8" name="Shape 6"/>
+          <p:cNvSpPr/>
+          <p:nvPr/>
+        </p:nvSpPr>
+        <p:spPr>
+          <a:xfrm>
+            <a:off x="5074920" y="2133307"/>
+            <a:ext cx="6611112" cy="3460065"/>
           </a:xfrm>
           <a:prstGeom prst="roundRect">
             <a:avLst>
-              <a:gd name="adj" fmla="val 8000"/>
+              <a:gd name="adj" fmla="val 2114"/>
             </a:avLst>
           </a:prstGeom>
           <a:solidFill>
-            <a:srgbClr val="0D1E33"/>
+            <a:srgbClr val="FFFFFF"/>
           </a:solidFill>
           <a:ln w="12700">
             <a:solidFill>
-              <a:srgbClr val="E8622C"/>
+              <a:srgbClr val="E2E6EA"/>
             </a:solidFill>
             <a:prstDash val="solid"/>
           </a:ln>
-        </p:spPr>
-      </p:sp>
-      <p:sp>
-        <p:nvSpPr>
-          <p:cNvPr id="14" name="Text 12"/>
-          <p:cNvSpPr/>
-          <p:nvPr/>
-        </p:nvSpPr>
-        <p:spPr>
-          <a:xfrm>
-            <a:off x="7543800" y="4818888"/>
-            <a:ext cx="3611880" cy="274320"/>
-          </a:xfrm>
-          <a:prstGeom prst="rect">
-            <a:avLst/>
-          </a:prstGeom>
-          <a:noFill/>
-          <a:ln/>
-        </p:spPr>
-        <p:txBody>
-          <a:bodyPr wrap="square" lIns="0" tIns="0" rIns="0" bIns="0" rtlCol="0" anchor="ctr"/>
-          <a:lstStyle/>
-          <a:p>
-            <a:pPr indent="0" marL="0">
-              <a:buNone/>
-            </a:pPr>
-            <a:r>
-              <a:rPr lang="en-US" sz="950" b="1" spc="150" kern="0" dirty="0">
-                <a:solidFill>
-                  <a:srgbClr val="E8622C"/>
-                </a:solidFill>
-                <a:latin typeface="Calibri" pitchFamily="34" charset="0"/>
-                <a:ea typeface="Calibri" pitchFamily="34" charset="-122"/>
-                <a:cs typeface="Calibri" pitchFamily="34" charset="-120"/>
-              </a:rPr>
-              <a:t>SOURCES</a:t>
-            </a:r>
-            <a:endParaRPr lang="en-US" sz="950" dirty="0"/>
-          </a:p>
-        </p:txBody>
-      </p:sp>
-      <p:sp>
-        <p:nvSpPr>
-          <p:cNvPr id="15" name="Text 13"/>
-          <p:cNvSpPr/>
-          <p:nvPr/>
-        </p:nvSpPr>
-        <p:spPr>
-          <a:xfrm>
-            <a:off x="7543800" y="5120640"/>
-            <a:ext cx="3611880" cy="365760"/>
-          </a:xfrm>
-          <a:prstGeom prst="rect">
-            <a:avLst/>
-          </a:prstGeom>
-          <a:noFill/>
-          <a:ln/>
-        </p:spPr>
-        <p:txBody>
-          <a:bodyPr wrap="square" lIns="0" tIns="0" rIns="0" bIns="0" rtlCol="0" anchor="ctr"/>
-          <a:lstStyle/>
-          <a:p>
-            <a:pPr indent="0" marL="0">
-              <a:buNone/>
-            </a:pPr>
-            <a:r>
-              <a:rPr lang="en-US" sz="1100" dirty="0">
-                <a:solidFill>
-                  <a:srgbClr val="C7D2DE"/>
-                </a:solidFill>
-                <a:latin typeface="Calibri" pitchFamily="34" charset="0"/>
-                <a:ea typeface="Calibri" pitchFamily="34" charset="-122"/>
-                <a:cs typeface="Calibri" pitchFamily="34" charset="-120"/>
-              </a:rPr>
-              <a:t>PRJ-0003 — Riyadh Hospital Project 3  (6 risk records)</a:t>
-            </a:r>
-            <a:endParaRPr lang="en-US" sz="1100" dirty="0"/>
-          </a:p>
-        </p:txBody>
-      </p:sp>
-      <p:sp>
-        <p:nvSpPr>
-          <p:cNvPr id="16" name="Text 14"/>
+          <a:effectLst>
+            <a:outerShdw sx="100000" sy="100000" kx="0" ky="0" algn="bl" rotWithShape="0" blurRad="127000" dist="38100" dir="5400000">
+              <a:srgbClr val="1F2937">
+                <a:alpha val="18000"/>
+              </a:srgbClr>
+            </a:outerShdw>
+          </a:effectLst>
+        </p:spPr>
+      </p:sp>
+      <p:pic>
+        <p:nvPicPr>
+          <p:cNvPr id="9" name="Image 0" descr="Copilot answering a grounded question about project risks with cited sources">    </p:cNvPr>
+          <p:cNvPicPr>
+            <a:picLocks noChangeAspect="1"/>
+          </p:cNvPicPr>
+          <p:nvPr/>
+        </p:nvPicPr>
+        <p:blipFill>
+          <a:blip r:embed="rId1"/>
+          <a:stretch>
+            <a:fillRect/>
+          </a:stretch>
+        </p:blipFill>
+        <p:spPr>
+          <a:xfrm>
+            <a:off x="5120640" y="2179027"/>
+            <a:ext cx="6519672" cy="3368625"/>
+          </a:xfrm>
+          <a:prstGeom prst="rect">
+            <a:avLst/>
+          </a:prstGeom>
+        </p:spPr>
+      </p:pic>
+      <p:sp>
+        <p:nvSpPr>
+          <p:cNvPr id="10" name="Text 7"/>
           <p:cNvSpPr/>
           <p:nvPr/>
         </p:nvSpPr>
@@ -10140,7 +9471,7 @@
           <a:bodyPr wrap="square" lIns="0" tIns="0" rIns="0" bIns="0" rtlCol="0" anchor="ctr"/>
           <a:lstStyle/>
           <a:p>
-            <a:pPr algn="l" indent="0" marL="0">
+            <a:pPr indent="0" marL="0">
               <a:buNone/>
             </a:pPr>
             <a:r>
@@ -10160,7 +9491,7 @@
       </p:sp>
       <p:sp>
         <p:nvSpPr>
-          <p:cNvPr id="17" name="Text 15"/>
+          <p:cNvPr id="11" name="Text 8"/>
           <p:cNvSpPr/>
           <p:nvPr/>
         </p:nvSpPr>
@@ -10276,27 +9607,31 @@
         </p:nvSpPr>
         <p:spPr>
           <a:xfrm>
-            <a:off x="548640" y="1508760"/>
-            <a:ext cx="11094415" cy="1234440"/>
-          </a:xfrm>
-          <a:prstGeom prst="rect">
-            <a:avLst/>
-          </a:prstGeom>
-          <a:noFill/>
-          <a:ln/>
-        </p:spPr>
-        <p:txBody>
-          <a:bodyPr wrap="square" lIns="0" tIns="0" rIns="0" bIns="0" rtlCol="0" anchor="ctr"/>
-          <a:lstStyle/>
-          <a:p>
-            <a:pPr indent="0" marL="0">
+            <a:off x="548640" y="1463040"/>
+            <a:ext cx="4206240" cy="4572000"/>
+          </a:xfrm>
+          <a:prstGeom prst="rect">
+            <a:avLst/>
+          </a:prstGeom>
+          <a:noFill/>
+          <a:ln/>
+        </p:spPr>
+        <p:txBody>
+          <a:bodyPr wrap="square" lIns="0" tIns="0" rIns="0" bIns="0" rtlCol="0" anchor="ctr"/>
+          <a:lstStyle/>
+          <a:p>
+            <a:pPr marL="177800" indent="-177800">
               <a:lnSpc>
-                <a:spcPct val="135000"/>
+                <a:spcPct val="130000"/>
               </a:lnSpc>
-              <a:buNone/>
-            </a:pPr>
-            <a:r>
-              <a:rPr lang="en-US" sz="1500" dirty="0">
+              <a:spcAft>
+                <a:spcPts val="1400"/>
+              </a:spcAft>
+              <a:buSzPct val="100000"/>
+              <a:buChar char="•"/>
+            </a:pPr>
+            <a:r>
+              <a:rPr lang="en-US" sz="1350" dirty="0">
                 <a:solidFill>
                   <a:srgbClr val="5B6B79"/>
                 </a:solidFill>
@@ -10304,9 +9639,81 @@
                 <a:ea typeface="Calibri" pitchFamily="34" charset="-122"/>
                 <a:cs typeface="Calibri" pitchFamily="34" charset="-120"/>
               </a:rPr>
-              <a:t>Given a goal in plain language, the agent chains the right tool calls — across all six workflows plus direct lookups — and returns a grounded answer with its full reasoning trail. It turns a solved task into a reusable skill, and every tool carries the same role restriction as its underlying API, even when a skill is replayed by someone else.</a:t>
-            </a:r>
-            <a:endParaRPr lang="en-US" sz="1500" dirty="0"/>
+              <a:t>Chains tool calls across all six workflows and direct lookups to reach a goal.</a:t>
+            </a:r>
+            <a:endParaRPr lang="en-US" sz="1350" dirty="0"/>
+          </a:p>
+          <a:p>
+            <a:pPr marL="177800" indent="-177800">
+              <a:lnSpc>
+                <a:spcPct val="130000"/>
+              </a:lnSpc>
+              <a:spcAft>
+                <a:spcPts val="1400"/>
+              </a:spcAft>
+              <a:buSzPct val="100000"/>
+              <a:buChar char="•"/>
+            </a:pPr>
+            <a:r>
+              <a:rPr lang="en-US" sz="1350" dirty="0">
+                <a:solidFill>
+                  <a:srgbClr val="5B6B79"/>
+                </a:solidFill>
+                <a:latin typeface="Calibri" pitchFamily="34" charset="0"/>
+                <a:ea typeface="Calibri" pitchFamily="34" charset="-122"/>
+                <a:cs typeface="Calibri" pitchFamily="34" charset="-120"/>
+              </a:rPr>
+              <a:t>Turns a solved task into a named, reusable skill — shown here, learned live.</a:t>
+            </a:r>
+            <a:endParaRPr lang="en-US" sz="1350" dirty="0"/>
+          </a:p>
+          <a:p>
+            <a:pPr marL="177800" indent="-177800">
+              <a:lnSpc>
+                <a:spcPct val="130000"/>
+              </a:lnSpc>
+              <a:spcAft>
+                <a:spcPts val="1400"/>
+              </a:spcAft>
+              <a:buSzPct val="100000"/>
+              <a:buChar char="•"/>
+            </a:pPr>
+            <a:r>
+              <a:rPr lang="en-US" sz="1350" dirty="0">
+                <a:solidFill>
+                  <a:srgbClr val="5B6B79"/>
+                </a:solidFill>
+                <a:latin typeface="Calibri" pitchFamily="34" charset="0"/>
+                <a:ea typeface="Calibri" pitchFamily="34" charset="-122"/>
+                <a:cs typeface="Calibri" pitchFamily="34" charset="-120"/>
+              </a:rPr>
+              <a:t>Every tool enforces the same RBAC as its direct API, even on a replayed skill.</a:t>
+            </a:r>
+            <a:endParaRPr lang="en-US" sz="1350" dirty="0"/>
+          </a:p>
+          <a:p>
+            <a:pPr marL="177800" indent="-177800">
+              <a:lnSpc>
+                <a:spcPct val="130000"/>
+              </a:lnSpc>
+              <a:spcAft>
+                <a:spcPts val="1400"/>
+              </a:spcAft>
+              <a:buSzPct val="100000"/>
+              <a:buChar char="•"/>
+            </a:pPr>
+            <a:r>
+              <a:rPr lang="en-US" sz="1350" dirty="0">
+                <a:solidFill>
+                  <a:srgbClr val="5B6B79"/>
+                </a:solidFill>
+                <a:latin typeface="Calibri" pitchFamily="34" charset="0"/>
+                <a:ea typeface="Calibri" pitchFamily="34" charset="-122"/>
+                <a:cs typeface="Calibri" pitchFamily="34" charset="-120"/>
+              </a:rPr>
+              <a:t>Treats retrieved content as data, never instructions — flags embedded overrides.</a:t>
+            </a:r>
+            <a:endParaRPr lang="en-US" sz="1350" dirty="0"/>
           </a:p>
         </p:txBody>
       </p:sp>
@@ -10318,43 +9725,35 @@
         </p:nvSpPr>
         <p:spPr>
           <a:xfrm>
-            <a:off x="548640" y="3017520"/>
-            <a:ext cx="2606040" cy="2651760"/>
+            <a:off x="5074920" y="2169750"/>
+            <a:ext cx="6611112" cy="3432899"/>
           </a:xfrm>
           <a:prstGeom prst="roundRect">
             <a:avLst>
-              <a:gd name="adj" fmla="val 4211"/>
+              <a:gd name="adj" fmla="val 2131"/>
             </a:avLst>
           </a:prstGeom>
           <a:solidFill>
-            <a:srgbClr val="F4F6F8"/>
+            <a:srgbClr val="FFFFFF"/>
           </a:solidFill>
-          <a:ln/>
-        </p:spPr>
-      </p:sp>
-      <p:sp>
-        <p:nvSpPr>
-          <p:cNvPr id="5" name="Shape 3"/>
-          <p:cNvSpPr/>
-          <p:nvPr/>
-        </p:nvSpPr>
-        <p:spPr>
-          <a:xfrm>
-            <a:off x="804672" y="3291840"/>
-            <a:ext cx="621792" cy="621792"/>
-          </a:xfrm>
-          <a:prstGeom prst="ellipse">
-            <a:avLst/>
-          </a:prstGeom>
-          <a:solidFill>
-            <a:srgbClr val="E8622C"/>
-          </a:solidFill>
-          <a:ln/>
+          <a:ln w="12700">
+            <a:solidFill>
+              <a:srgbClr val="E2E6EA"/>
+            </a:solidFill>
+            <a:prstDash val="solid"/>
+          </a:ln>
+          <a:effectLst>
+            <a:outerShdw sx="100000" sy="100000" kx="0" ky="0" algn="bl" rotWithShape="0" blurRad="127000" dist="38100" dir="5400000">
+              <a:srgbClr val="1F2937">
+                <a:alpha val="18000"/>
+              </a:srgbClr>
+            </a:outerShdw>
+          </a:effectLst>
         </p:spPr>
       </p:sp>
       <p:pic>
         <p:nvPicPr>
-          <p:cNvPr id="6" name="Image 0" descr="preencoded.png">    </p:cNvPr>
+          <p:cNvPr id="5" name="Image 0" descr="Agent conversation showing a completed run, its tool steps, and a learned reusable skill">    </p:cNvPr>
           <p:cNvPicPr>
             <a:picLocks noChangeAspect="1"/>
           </p:cNvPicPr>
@@ -10368,8 +9767,8 @@
         </p:blipFill>
         <p:spPr>
           <a:xfrm>
-            <a:off x="944575" y="3431743"/>
-            <a:ext cx="341986" cy="341986"/>
+            <a:off x="5120640" y="2215470"/>
+            <a:ext cx="6519672" cy="3341459"/>
           </a:xfrm>
           <a:prstGeom prst="rect">
             <a:avLst/>
@@ -10378,529 +9777,7 @@
       </p:pic>
       <p:sp>
         <p:nvSpPr>
-          <p:cNvPr id="7" name="Text 4"/>
-          <p:cNvSpPr/>
-          <p:nvPr/>
-        </p:nvSpPr>
-        <p:spPr>
-          <a:xfrm>
-            <a:off x="749808" y="4114800"/>
-            <a:ext cx="2203704" cy="502920"/>
-          </a:xfrm>
-          <a:prstGeom prst="rect">
-            <a:avLst/>
-          </a:prstGeom>
-          <a:noFill/>
-          <a:ln/>
-        </p:spPr>
-        <p:txBody>
-          <a:bodyPr wrap="square" lIns="0" tIns="0" rIns="0" bIns="0" rtlCol="0" anchor="ctr"/>
-          <a:lstStyle/>
-          <a:p>
-            <a:pPr indent="0" marL="0">
-              <a:buNone/>
-            </a:pPr>
-            <a:r>
-              <a:rPr lang="en-US" sz="1400" b="1" dirty="0">
-                <a:solidFill>
-                  <a:srgbClr val="132A46"/>
-                </a:solidFill>
-                <a:latin typeface="Calibri" pitchFamily="34" charset="0"/>
-                <a:ea typeface="Calibri" pitchFamily="34" charset="-122"/>
-                <a:cs typeface="Calibri" pitchFamily="34" charset="-120"/>
-              </a:rPr>
-              <a:t>Plans, then acts</a:t>
-            </a:r>
-            <a:endParaRPr lang="en-US" sz="1400" dirty="0"/>
-          </a:p>
-        </p:txBody>
-      </p:sp>
-      <p:sp>
-        <p:nvSpPr>
-          <p:cNvPr id="8" name="Text 5"/>
-          <p:cNvSpPr/>
-          <p:nvPr/>
-        </p:nvSpPr>
-        <p:spPr>
-          <a:xfrm>
-            <a:off x="749808" y="4709160"/>
-            <a:ext cx="2203704" cy="914400"/>
-          </a:xfrm>
-          <a:prstGeom prst="rect">
-            <a:avLst/>
-          </a:prstGeom>
-          <a:noFill/>
-          <a:ln/>
-        </p:spPr>
-        <p:txBody>
-          <a:bodyPr wrap="square" lIns="0" tIns="0" rIns="0" bIns="0" rtlCol="0" anchor="ctr"/>
-          <a:lstStyle/>
-          <a:p>
-            <a:pPr indent="0" marL="0">
-              <a:lnSpc>
-                <a:spcPct val="125000"/>
-              </a:lnSpc>
-              <a:buNone/>
-            </a:pPr>
-            <a:r>
-              <a:rPr lang="en-US" sz="1100" dirty="0">
-                <a:solidFill>
-                  <a:srgbClr val="5B6B79"/>
-                </a:solidFill>
-                <a:latin typeface="Calibri" pitchFamily="34" charset="0"/>
-                <a:ea typeface="Calibri" pitchFamily="34" charset="-122"/>
-                <a:cs typeface="Calibri" pitchFamily="34" charset="-120"/>
-              </a:rPr>
-              <a:t>Chains tool calls across workflows and direct lookups to reach a goal.</a:t>
-            </a:r>
-            <a:endParaRPr lang="en-US" sz="1100" dirty="0"/>
-          </a:p>
-        </p:txBody>
-      </p:sp>
-      <p:sp>
-        <p:nvSpPr>
-          <p:cNvPr id="9" name="Shape 6"/>
-          <p:cNvSpPr/>
-          <p:nvPr/>
-        </p:nvSpPr>
-        <p:spPr>
-          <a:xfrm>
-            <a:off x="3410712" y="3017520"/>
-            <a:ext cx="2606040" cy="2651760"/>
-          </a:xfrm>
-          <a:prstGeom prst="roundRect">
-            <a:avLst>
-              <a:gd name="adj" fmla="val 4211"/>
-            </a:avLst>
-          </a:prstGeom>
-          <a:solidFill>
-            <a:srgbClr val="F4F6F8"/>
-          </a:solidFill>
-          <a:ln/>
-        </p:spPr>
-      </p:sp>
-      <p:sp>
-        <p:nvSpPr>
-          <p:cNvPr id="10" name="Shape 7"/>
-          <p:cNvSpPr/>
-          <p:nvPr/>
-        </p:nvSpPr>
-        <p:spPr>
-          <a:xfrm>
-            <a:off x="3666744" y="3291840"/>
-            <a:ext cx="621792" cy="621792"/>
-          </a:xfrm>
-          <a:prstGeom prst="ellipse">
-            <a:avLst/>
-          </a:prstGeom>
-          <a:solidFill>
-            <a:srgbClr val="132A46"/>
-          </a:solidFill>
-          <a:ln/>
-        </p:spPr>
-      </p:sp>
-      <p:pic>
-        <p:nvPicPr>
-          <p:cNvPr id="11" name="Image 1" descr="preencoded.png">    </p:cNvPr>
-          <p:cNvPicPr>
-            <a:picLocks noChangeAspect="1"/>
-          </p:cNvPicPr>
-          <p:nvPr/>
-        </p:nvPicPr>
-        <p:blipFill>
-          <a:blip r:embed="rId2"/>
-          <a:stretch>
-            <a:fillRect/>
-          </a:stretch>
-        </p:blipFill>
-        <p:spPr>
-          <a:xfrm>
-            <a:off x="3806647" y="3431743"/>
-            <a:ext cx="341986" cy="341986"/>
-          </a:xfrm>
-          <a:prstGeom prst="rect">
-            <a:avLst/>
-          </a:prstGeom>
-        </p:spPr>
-      </p:pic>
-      <p:sp>
-        <p:nvSpPr>
-          <p:cNvPr id="12" name="Text 8"/>
-          <p:cNvSpPr/>
-          <p:nvPr/>
-        </p:nvSpPr>
-        <p:spPr>
-          <a:xfrm>
-            <a:off x="3611880" y="4114800"/>
-            <a:ext cx="2203704" cy="502920"/>
-          </a:xfrm>
-          <a:prstGeom prst="rect">
-            <a:avLst/>
-          </a:prstGeom>
-          <a:noFill/>
-          <a:ln/>
-        </p:spPr>
-        <p:txBody>
-          <a:bodyPr wrap="square" lIns="0" tIns="0" rIns="0" bIns="0" rtlCol="0" anchor="ctr"/>
-          <a:lstStyle/>
-          <a:p>
-            <a:pPr indent="0" marL="0">
-              <a:buNone/>
-            </a:pPr>
-            <a:r>
-              <a:rPr lang="en-US" sz="1400" b="1" dirty="0">
-                <a:solidFill>
-                  <a:srgbClr val="132A46"/>
-                </a:solidFill>
-                <a:latin typeface="Calibri" pitchFamily="34" charset="0"/>
-                <a:ea typeface="Calibri" pitchFamily="34" charset="-122"/>
-                <a:cs typeface="Calibri" pitchFamily="34" charset="-120"/>
-              </a:rPr>
-              <a:t>Reusable skills</a:t>
-            </a:r>
-            <a:endParaRPr lang="en-US" sz="1400" dirty="0"/>
-          </a:p>
-        </p:txBody>
-      </p:sp>
-      <p:sp>
-        <p:nvSpPr>
-          <p:cNvPr id="13" name="Text 9"/>
-          <p:cNvSpPr/>
-          <p:nvPr/>
-        </p:nvSpPr>
-        <p:spPr>
-          <a:xfrm>
-            <a:off x="3611880" y="4709160"/>
-            <a:ext cx="2203704" cy="914400"/>
-          </a:xfrm>
-          <a:prstGeom prst="rect">
-            <a:avLst/>
-          </a:prstGeom>
-          <a:noFill/>
-          <a:ln/>
-        </p:spPr>
-        <p:txBody>
-          <a:bodyPr wrap="square" lIns="0" tIns="0" rIns="0" bIns="0" rtlCol="0" anchor="ctr"/>
-          <a:lstStyle/>
-          <a:p>
-            <a:pPr indent="0" marL="0">
-              <a:lnSpc>
-                <a:spcPct val="125000"/>
-              </a:lnSpc>
-              <a:buNone/>
-            </a:pPr>
-            <a:r>
-              <a:rPr lang="en-US" sz="1100" dirty="0">
-                <a:solidFill>
-                  <a:srgbClr val="5B6B79"/>
-                </a:solidFill>
-                <a:latin typeface="Calibri" pitchFamily="34" charset="0"/>
-                <a:ea typeface="Calibri" pitchFamily="34" charset="-122"/>
-                <a:cs typeface="Calibri" pitchFamily="34" charset="-120"/>
-              </a:rPr>
-              <a:t>Stores a solved task as a named, parameterized skill and reuses it on similar goals.</a:t>
-            </a:r>
-            <a:endParaRPr lang="en-US" sz="1100" dirty="0"/>
-          </a:p>
-        </p:txBody>
-      </p:sp>
-      <p:sp>
-        <p:nvSpPr>
-          <p:cNvPr id="14" name="Shape 10"/>
-          <p:cNvSpPr/>
-          <p:nvPr/>
-        </p:nvSpPr>
-        <p:spPr>
-          <a:xfrm>
-            <a:off x="6272784" y="3017520"/>
-            <a:ext cx="2606040" cy="2651760"/>
-          </a:xfrm>
-          <a:prstGeom prst="roundRect">
-            <a:avLst>
-              <a:gd name="adj" fmla="val 4211"/>
-            </a:avLst>
-          </a:prstGeom>
-          <a:solidFill>
-            <a:srgbClr val="F4F6F8"/>
-          </a:solidFill>
-          <a:ln/>
-        </p:spPr>
-      </p:sp>
-      <p:sp>
-        <p:nvSpPr>
-          <p:cNvPr id="15" name="Shape 11"/>
-          <p:cNvSpPr/>
-          <p:nvPr/>
-        </p:nvSpPr>
-        <p:spPr>
-          <a:xfrm>
-            <a:off x="6528816" y="3291840"/>
-            <a:ext cx="621792" cy="621792"/>
-          </a:xfrm>
-          <a:prstGeom prst="ellipse">
-            <a:avLst/>
-          </a:prstGeom>
-          <a:solidFill>
-            <a:srgbClr val="132A46"/>
-          </a:solidFill>
-          <a:ln/>
-        </p:spPr>
-      </p:sp>
-      <p:pic>
-        <p:nvPicPr>
-          <p:cNvPr id="16" name="Image 2" descr="preencoded.png">    </p:cNvPr>
-          <p:cNvPicPr>
-            <a:picLocks noChangeAspect="1"/>
-          </p:cNvPicPr>
-          <p:nvPr/>
-        </p:nvPicPr>
-        <p:blipFill>
-          <a:blip r:embed="rId3"/>
-          <a:stretch>
-            <a:fillRect/>
-          </a:stretch>
-        </p:blipFill>
-        <p:spPr>
-          <a:xfrm>
-            <a:off x="6668719" y="3431743"/>
-            <a:ext cx="341986" cy="341986"/>
-          </a:xfrm>
-          <a:prstGeom prst="rect">
-            <a:avLst/>
-          </a:prstGeom>
-        </p:spPr>
-      </p:pic>
-      <p:sp>
-        <p:nvSpPr>
-          <p:cNvPr id="17" name="Text 12"/>
-          <p:cNvSpPr/>
-          <p:nvPr/>
-        </p:nvSpPr>
-        <p:spPr>
-          <a:xfrm>
-            <a:off x="6473952" y="4114800"/>
-            <a:ext cx="2203704" cy="502920"/>
-          </a:xfrm>
-          <a:prstGeom prst="rect">
-            <a:avLst/>
-          </a:prstGeom>
-          <a:noFill/>
-          <a:ln/>
-        </p:spPr>
-        <p:txBody>
-          <a:bodyPr wrap="square" lIns="0" tIns="0" rIns="0" bIns="0" rtlCol="0" anchor="ctr"/>
-          <a:lstStyle/>
-          <a:p>
-            <a:pPr indent="0" marL="0">
-              <a:buNone/>
-            </a:pPr>
-            <a:r>
-              <a:rPr lang="en-US" sz="1400" b="1" dirty="0">
-                <a:solidFill>
-                  <a:srgbClr val="132A46"/>
-                </a:solidFill>
-                <a:latin typeface="Calibri" pitchFamily="34" charset="0"/>
-                <a:ea typeface="Calibri" pitchFamily="34" charset="-122"/>
-                <a:cs typeface="Calibri" pitchFamily="34" charset="-120"/>
-              </a:rPr>
-              <a:t>Governed everywhere</a:t>
-            </a:r>
-            <a:endParaRPr lang="en-US" sz="1400" dirty="0"/>
-          </a:p>
-        </p:txBody>
-      </p:sp>
-      <p:sp>
-        <p:nvSpPr>
-          <p:cNvPr id="18" name="Text 13"/>
-          <p:cNvSpPr/>
-          <p:nvPr/>
-        </p:nvSpPr>
-        <p:spPr>
-          <a:xfrm>
-            <a:off x="6473952" y="4709160"/>
-            <a:ext cx="2203704" cy="914400"/>
-          </a:xfrm>
-          <a:prstGeom prst="rect">
-            <a:avLst/>
-          </a:prstGeom>
-          <a:noFill/>
-          <a:ln/>
-        </p:spPr>
-        <p:txBody>
-          <a:bodyPr wrap="square" lIns="0" tIns="0" rIns="0" bIns="0" rtlCol="0" anchor="ctr"/>
-          <a:lstStyle/>
-          <a:p>
-            <a:pPr indent="0" marL="0">
-              <a:lnSpc>
-                <a:spcPct val="125000"/>
-              </a:lnSpc>
-              <a:buNone/>
-            </a:pPr>
-            <a:r>
-              <a:rPr lang="en-US" sz="1100" dirty="0">
-                <a:solidFill>
-                  <a:srgbClr val="5B6B79"/>
-                </a:solidFill>
-                <a:latin typeface="Calibri" pitchFamily="34" charset="0"/>
-                <a:ea typeface="Calibri" pitchFamily="34" charset="-122"/>
-                <a:cs typeface="Calibri" pitchFamily="34" charset="-120"/>
-              </a:rPr>
-              <a:t>Each tool enforces the same RBAC as its direct API — no bypass through the agent.</a:t>
-            </a:r>
-            <a:endParaRPr lang="en-US" sz="1100" dirty="0"/>
-          </a:p>
-        </p:txBody>
-      </p:sp>
-      <p:sp>
-        <p:nvSpPr>
-          <p:cNvPr id="19" name="Shape 14"/>
-          <p:cNvSpPr/>
-          <p:nvPr/>
-        </p:nvSpPr>
-        <p:spPr>
-          <a:xfrm>
-            <a:off x="9134856" y="3017520"/>
-            <a:ext cx="2606040" cy="2651760"/>
-          </a:xfrm>
-          <a:prstGeom prst="roundRect">
-            <a:avLst>
-              <a:gd name="adj" fmla="val 4211"/>
-            </a:avLst>
-          </a:prstGeom>
-          <a:solidFill>
-            <a:srgbClr val="F4F6F8"/>
-          </a:solidFill>
-          <a:ln/>
-        </p:spPr>
-      </p:sp>
-      <p:sp>
-        <p:nvSpPr>
-          <p:cNvPr id="20" name="Shape 15"/>
-          <p:cNvSpPr/>
-          <p:nvPr/>
-        </p:nvSpPr>
-        <p:spPr>
-          <a:xfrm>
-            <a:off x="9390888" y="3291840"/>
-            <a:ext cx="621792" cy="621792"/>
-          </a:xfrm>
-          <a:prstGeom prst="ellipse">
-            <a:avLst/>
-          </a:prstGeom>
-          <a:solidFill>
-            <a:srgbClr val="132A46"/>
-          </a:solidFill>
-          <a:ln/>
-        </p:spPr>
-      </p:sp>
-      <p:pic>
-        <p:nvPicPr>
-          <p:cNvPr id="21" name="Image 3" descr="preencoded.png">    </p:cNvPr>
-          <p:cNvPicPr>
-            <a:picLocks noChangeAspect="1"/>
-          </p:cNvPicPr>
-          <p:nvPr/>
-        </p:nvPicPr>
-        <p:blipFill>
-          <a:blip r:embed="rId4"/>
-          <a:stretch>
-            <a:fillRect/>
-          </a:stretch>
-        </p:blipFill>
-        <p:spPr>
-          <a:xfrm>
-            <a:off x="9530791" y="3431743"/>
-            <a:ext cx="341986" cy="341986"/>
-          </a:xfrm>
-          <a:prstGeom prst="rect">
-            <a:avLst/>
-          </a:prstGeom>
-        </p:spPr>
-      </p:pic>
-      <p:sp>
-        <p:nvSpPr>
-          <p:cNvPr id="22" name="Text 16"/>
-          <p:cNvSpPr/>
-          <p:nvPr/>
-        </p:nvSpPr>
-        <p:spPr>
-          <a:xfrm>
-            <a:off x="9336024" y="4114800"/>
-            <a:ext cx="2203704" cy="502920"/>
-          </a:xfrm>
-          <a:prstGeom prst="rect">
-            <a:avLst/>
-          </a:prstGeom>
-          <a:noFill/>
-          <a:ln/>
-        </p:spPr>
-        <p:txBody>
-          <a:bodyPr wrap="square" lIns="0" tIns="0" rIns="0" bIns="0" rtlCol="0" anchor="ctr"/>
-          <a:lstStyle/>
-          <a:p>
-            <a:pPr indent="0" marL="0">
-              <a:buNone/>
-            </a:pPr>
-            <a:r>
-              <a:rPr lang="en-US" sz="1400" b="1" dirty="0">
-                <a:solidFill>
-                  <a:srgbClr val="132A46"/>
-                </a:solidFill>
-                <a:latin typeface="Calibri" pitchFamily="34" charset="0"/>
-                <a:ea typeface="Calibri" pitchFamily="34" charset="-122"/>
-                <a:cs typeface="Calibri" pitchFamily="34" charset="-120"/>
-              </a:rPr>
-              <a:t>Poison-resistant</a:t>
-            </a:r>
-            <a:endParaRPr lang="en-US" sz="1400" dirty="0"/>
-          </a:p>
-        </p:txBody>
-      </p:sp>
-      <p:sp>
-        <p:nvSpPr>
-          <p:cNvPr id="23" name="Text 17"/>
-          <p:cNvSpPr/>
-          <p:nvPr/>
-        </p:nvSpPr>
-        <p:spPr>
-          <a:xfrm>
-            <a:off x="9336024" y="4709160"/>
-            <a:ext cx="2203704" cy="914400"/>
-          </a:xfrm>
-          <a:prstGeom prst="rect">
-            <a:avLst/>
-          </a:prstGeom>
-          <a:noFill/>
-          <a:ln/>
-        </p:spPr>
-        <p:txBody>
-          <a:bodyPr wrap="square" lIns="0" tIns="0" rIns="0" bIns="0" rtlCol="0" anchor="ctr"/>
-          <a:lstStyle/>
-          <a:p>
-            <a:pPr indent="0" marL="0">
-              <a:lnSpc>
-                <a:spcPct val="125000"/>
-              </a:lnSpc>
-              <a:buNone/>
-            </a:pPr>
-            <a:r>
-              <a:rPr lang="en-US" sz="1100" dirty="0">
-                <a:solidFill>
-                  <a:srgbClr val="5B6B79"/>
-                </a:solidFill>
-                <a:latin typeface="Calibri" pitchFamily="34" charset="0"/>
-                <a:ea typeface="Calibri" pitchFamily="34" charset="-122"/>
-                <a:cs typeface="Calibri" pitchFamily="34" charset="-120"/>
-              </a:rPr>
-              <a:t>Treats retrieved content as data, never instructions — flags embedded overrides before they reach the model.</a:t>
-            </a:r>
-            <a:endParaRPr lang="en-US" sz="1100" dirty="0"/>
-          </a:p>
-        </p:txBody>
-      </p:sp>
-      <p:sp>
-        <p:nvSpPr>
-          <p:cNvPr id="24" name="Text 18"/>
+          <p:cNvPr id="6" name="Text 3"/>
           <p:cNvSpPr/>
           <p:nvPr/>
         </p:nvSpPr>
@@ -10919,7 +9796,7 @@
           <a:bodyPr wrap="square" lIns="0" tIns="0" rIns="0" bIns="0" rtlCol="0" anchor="ctr"/>
           <a:lstStyle/>
           <a:p>
-            <a:pPr algn="l" indent="0" marL="0">
+            <a:pPr indent="0" marL="0">
               <a:buNone/>
             </a:pPr>
             <a:r>
@@ -10939,7 +9816,7 @@
       </p:sp>
       <p:sp>
         <p:nvSpPr>
-          <p:cNvPr id="25" name="Text 19"/>
+          <p:cNvPr id="7" name="Text 4"/>
           <p:cNvSpPr/>
           <p:nvPr/>
         </p:nvSpPr>
@@ -11049,27 +9926,159 @@
       </p:sp>
       <p:sp>
         <p:nvSpPr>
-          <p:cNvPr id="3" name="Shape 1"/>
-          <p:cNvSpPr/>
-          <p:nvPr/>
-        </p:nvSpPr>
-        <p:spPr>
-          <a:xfrm>
-            <a:off x="548640" y="1508760"/>
-            <a:ext cx="566928" cy="566928"/>
-          </a:xfrm>
-          <a:prstGeom prst="ellipse">
-            <a:avLst/>
+          <p:cNvPr id="3" name="Text 1"/>
+          <p:cNvSpPr/>
+          <p:nvPr/>
+        </p:nvSpPr>
+        <p:spPr>
+          <a:xfrm>
+            <a:off x="548640" y="1463040"/>
+            <a:ext cx="4206240" cy="4572000"/>
+          </a:xfrm>
+          <a:prstGeom prst="rect">
+            <a:avLst/>
+          </a:prstGeom>
+          <a:noFill/>
+          <a:ln/>
+        </p:spPr>
+        <p:txBody>
+          <a:bodyPr wrap="square" lIns="0" tIns="0" rIns="0" bIns="0" rtlCol="0" anchor="ctr"/>
+          <a:lstStyle/>
+          <a:p>
+            <a:pPr marL="177800" indent="-177800">
+              <a:lnSpc>
+                <a:spcPct val="130000"/>
+              </a:lnSpc>
+              <a:spcAft>
+                <a:spcPts val="1400"/>
+              </a:spcAft>
+              <a:buSzPct val="100000"/>
+              <a:buChar char="•"/>
+            </a:pPr>
+            <a:r>
+              <a:rPr lang="en-US" sz="1350" dirty="0">
+                <a:solidFill>
+                  <a:srgbClr val="5B6B79"/>
+                </a:solidFill>
+                <a:latin typeface="Calibri" pitchFamily="34" charset="0"/>
+                <a:ea typeface="Calibri" pitchFamily="34" charset="-122"/>
+                <a:cs typeface="Calibri" pitchFamily="34" charset="-120"/>
+              </a:rPr>
+              <a:t>Any sensitive action becomes an approval request — the AI never executes alone.</a:t>
+            </a:r>
+            <a:endParaRPr lang="en-US" sz="1350" dirty="0"/>
+          </a:p>
+          <a:p>
+            <a:pPr marL="177800" indent="-177800">
+              <a:lnSpc>
+                <a:spcPct val="130000"/>
+              </a:lnSpc>
+              <a:spcAft>
+                <a:spcPts val="1400"/>
+              </a:spcAft>
+              <a:buSzPct val="100000"/>
+              <a:buChar char="•"/>
+            </a:pPr>
+            <a:r>
+              <a:rPr lang="en-US" sz="1350" dirty="0">
+                <a:solidFill>
+                  <a:srgbClr val="5B6B79"/>
+                </a:solidFill>
+                <a:latin typeface="Calibri" pitchFamily="34" charset="0"/>
+                <a:ea typeface="Calibri" pitchFamily="34" charset="-122"/>
+                <a:cs typeface="Calibri" pitchFamily="34" charset="-120"/>
+              </a:rPr>
+              <a:t>Approving it moves the record forward: the request itself becomes Approved.</a:t>
+            </a:r>
+            <a:endParaRPr lang="en-US" sz="1350" dirty="0"/>
+          </a:p>
+          <a:p>
+            <a:pPr marL="177800" indent="-177800">
+              <a:lnSpc>
+                <a:spcPct val="130000"/>
+              </a:lnSpc>
+              <a:spcAft>
+                <a:spcPts val="1400"/>
+              </a:spcAft>
+              <a:buSzPct val="100000"/>
+              <a:buChar char="•"/>
+            </a:pPr>
+            <a:r>
+              <a:rPr lang="en-US" sz="1350" dirty="0">
+                <a:solidFill>
+                  <a:srgbClr val="5B6B79"/>
+                </a:solidFill>
+                <a:latin typeface="Calibri" pitchFamily="34" charset="0"/>
+                <a:ea typeface="Calibri" pitchFamily="34" charset="-122"/>
+                <a:cs typeface="Calibri" pitchFamily="34" charset="-120"/>
+              </a:rPr>
+              <a:t>Seven-role RBAC; every route and every agent tool checks the same gate.</a:t>
+            </a:r>
+            <a:endParaRPr lang="en-US" sz="1350" dirty="0"/>
+          </a:p>
+          <a:p>
+            <a:pPr marL="177800" indent="-177800">
+              <a:lnSpc>
+                <a:spcPct val="130000"/>
+              </a:lnSpc>
+              <a:spcAft>
+                <a:spcPts val="1400"/>
+              </a:spcAft>
+              <a:buSzPct val="100000"/>
+              <a:buChar char="•"/>
+            </a:pPr>
+            <a:r>
+              <a:rPr lang="en-US" sz="1350" dirty="0">
+                <a:solidFill>
+                  <a:srgbClr val="5B6B79"/>
+                </a:solidFill>
+                <a:latin typeface="Calibri" pitchFamily="34" charset="0"/>
+                <a:ea typeface="Calibri" pitchFamily="34" charset="-122"/>
+                <a:cs typeface="Calibri" pitchFamily="34" charset="-120"/>
+              </a:rPr>
+              <a:t>Every AI call is logged: who asked, what ran, and what it returned.</a:t>
+            </a:r>
+            <a:endParaRPr lang="en-US" sz="1350" dirty="0"/>
+          </a:p>
+        </p:txBody>
+      </p:sp>
+      <p:sp>
+        <p:nvSpPr>
+          <p:cNvPr id="4" name="Shape 2"/>
+          <p:cNvSpPr/>
+          <p:nvPr/>
+        </p:nvSpPr>
+        <p:spPr>
+          <a:xfrm>
+            <a:off x="5372200" y="1371600"/>
+            <a:ext cx="6016553" cy="4983480"/>
+          </a:xfrm>
+          <a:prstGeom prst="roundRect">
+            <a:avLst>
+              <a:gd name="adj" fmla="val 1468"/>
+            </a:avLst>
           </a:prstGeom>
           <a:solidFill>
-            <a:srgbClr val="132A46"/>
+            <a:srgbClr val="FFFFFF"/>
           </a:solidFill>
-          <a:ln/>
+          <a:ln w="12700">
+            <a:solidFill>
+              <a:srgbClr val="E2E6EA"/>
+            </a:solidFill>
+            <a:prstDash val="solid"/>
+          </a:ln>
+          <a:effectLst>
+            <a:outerShdw sx="100000" sy="100000" kx="0" ky="0" algn="bl" rotWithShape="0" blurRad="127000" dist="38100" dir="5400000">
+              <a:srgbClr val="1F2937">
+                <a:alpha val="18000"/>
+              </a:srgbClr>
+            </a:outerShdw>
+          </a:effectLst>
         </p:spPr>
       </p:sp>
       <p:pic>
         <p:nvPicPr>
-          <p:cNvPr id="4" name="Image 0" descr="preencoded.png">    </p:cNvPr>
+          <p:cNvPr id="5" name="Image 0" descr="Approval request modal and the AI audit trail logging every AI call">    </p:cNvPr>
           <p:cNvPicPr>
             <a:picLocks noChangeAspect="1"/>
           </p:cNvPicPr>
@@ -11083,8 +10092,8 @@
         </p:blipFill>
         <p:spPr>
           <a:xfrm>
-            <a:off x="676199" y="1636319"/>
-            <a:ext cx="311810" cy="311810"/>
+            <a:off x="5417920" y="1417320"/>
+            <a:ext cx="5925113" cy="4892040"/>
           </a:xfrm>
           <a:prstGeom prst="rect">
             <a:avLst/>
@@ -11093,713 +10102,7 @@
       </p:pic>
       <p:sp>
         <p:nvSpPr>
-          <p:cNvPr id="5" name="Text 2"/>
-          <p:cNvSpPr/>
-          <p:nvPr/>
-        </p:nvSpPr>
-        <p:spPr>
-          <a:xfrm>
-            <a:off x="1325880" y="1463040"/>
-            <a:ext cx="4617720" cy="365760"/>
-          </a:xfrm>
-          <a:prstGeom prst="rect">
-            <a:avLst/>
-          </a:prstGeom>
-          <a:noFill/>
-          <a:ln/>
-        </p:spPr>
-        <p:txBody>
-          <a:bodyPr wrap="square" lIns="0" tIns="0" rIns="0" bIns="0" rtlCol="0" anchor="ctr"/>
-          <a:lstStyle/>
-          <a:p>
-            <a:pPr indent="0" marL="0">
-              <a:buNone/>
-            </a:pPr>
-            <a:r>
-              <a:rPr lang="en-US" sz="1450" b="1" dirty="0">
-                <a:solidFill>
-                  <a:srgbClr val="132A46"/>
-                </a:solidFill>
-                <a:latin typeface="Calibri" pitchFamily="34" charset="0"/>
-                <a:ea typeface="Calibri" pitchFamily="34" charset="-122"/>
-                <a:cs typeface="Calibri" pitchFamily="34" charset="-120"/>
-              </a:rPr>
-              <a:t>JWT authentication</a:t>
-            </a:r>
-            <a:endParaRPr lang="en-US" sz="1450" dirty="0"/>
-          </a:p>
-        </p:txBody>
-      </p:sp>
-      <p:sp>
-        <p:nvSpPr>
           <p:cNvPr id="6" name="Text 3"/>
-          <p:cNvSpPr/>
-          <p:nvPr/>
-        </p:nvSpPr>
-        <p:spPr>
-          <a:xfrm>
-            <a:off x="1325880" y="1847088"/>
-            <a:ext cx="4617720" cy="822960"/>
-          </a:xfrm>
-          <a:prstGeom prst="rect">
-            <a:avLst/>
-          </a:prstGeom>
-          <a:noFill/>
-          <a:ln/>
-        </p:spPr>
-        <p:txBody>
-          <a:bodyPr wrap="square" lIns="0" tIns="0" rIns="0" bIns="0" rtlCol="0" anchor="ctr"/>
-          <a:lstStyle/>
-          <a:p>
-            <a:pPr indent="0" marL="0">
-              <a:lnSpc>
-                <a:spcPct val="125000"/>
-              </a:lnSpc>
-              <a:buNone/>
-            </a:pPr>
-            <a:r>
-              <a:rPr lang="en-US" sz="1200" dirty="0">
-                <a:solidFill>
-                  <a:srgbClr val="5B6B79"/>
-                </a:solidFill>
-                <a:latin typeface="Calibri" pitchFamily="34" charset="0"/>
-                <a:ea typeface="Calibri" pitchFamily="34" charset="-122"/>
-                <a:cs typeface="Calibri" pitchFamily="34" charset="-120"/>
-              </a:rPr>
-              <a:t>Enforced with a non-default secret required outside development.</a:t>
-            </a:r>
-            <a:endParaRPr lang="en-US" sz="1200" dirty="0"/>
-          </a:p>
-        </p:txBody>
-      </p:sp>
-      <p:sp>
-        <p:nvSpPr>
-          <p:cNvPr id="7" name="Shape 4"/>
-          <p:cNvSpPr/>
-          <p:nvPr/>
-        </p:nvSpPr>
-        <p:spPr>
-          <a:xfrm>
-            <a:off x="548640" y="2926080"/>
-            <a:ext cx="566928" cy="566928"/>
-          </a:xfrm>
-          <a:prstGeom prst="ellipse">
-            <a:avLst/>
-          </a:prstGeom>
-          <a:solidFill>
-            <a:srgbClr val="132A46"/>
-          </a:solidFill>
-          <a:ln/>
-        </p:spPr>
-      </p:sp>
-      <p:pic>
-        <p:nvPicPr>
-          <p:cNvPr id="8" name="Image 1" descr="preencoded.png">    </p:cNvPr>
-          <p:cNvPicPr>
-            <a:picLocks noChangeAspect="1"/>
-          </p:cNvPicPr>
-          <p:nvPr/>
-        </p:nvPicPr>
-        <p:blipFill>
-          <a:blip r:embed="rId2"/>
-          <a:stretch>
-            <a:fillRect/>
-          </a:stretch>
-        </p:blipFill>
-        <p:spPr>
-          <a:xfrm>
-            <a:off x="676199" y="3053639"/>
-            <a:ext cx="311810" cy="311810"/>
-          </a:xfrm>
-          <a:prstGeom prst="rect">
-            <a:avLst/>
-          </a:prstGeom>
-        </p:spPr>
-      </p:pic>
-      <p:sp>
-        <p:nvSpPr>
-          <p:cNvPr id="9" name="Text 5"/>
-          <p:cNvSpPr/>
-          <p:nvPr/>
-        </p:nvSpPr>
-        <p:spPr>
-          <a:xfrm>
-            <a:off x="1325880" y="2880360"/>
-            <a:ext cx="4617720" cy="365760"/>
-          </a:xfrm>
-          <a:prstGeom prst="rect">
-            <a:avLst/>
-          </a:prstGeom>
-          <a:noFill/>
-          <a:ln/>
-        </p:spPr>
-        <p:txBody>
-          <a:bodyPr wrap="square" lIns="0" tIns="0" rIns="0" bIns="0" rtlCol="0" anchor="ctr"/>
-          <a:lstStyle/>
-          <a:p>
-            <a:pPr indent="0" marL="0">
-              <a:buNone/>
-            </a:pPr>
-            <a:r>
-              <a:rPr lang="en-US" sz="1450" b="1" dirty="0">
-                <a:solidFill>
-                  <a:srgbClr val="132A46"/>
-                </a:solidFill>
-                <a:latin typeface="Calibri" pitchFamily="34" charset="0"/>
-                <a:ea typeface="Calibri" pitchFamily="34" charset="-122"/>
-                <a:cs typeface="Calibri" pitchFamily="34" charset="-120"/>
-              </a:rPr>
-              <a:t>Seven-role RBAC</a:t>
-            </a:r>
-            <a:endParaRPr lang="en-US" sz="1450" dirty="0"/>
-          </a:p>
-        </p:txBody>
-      </p:sp>
-      <p:sp>
-        <p:nvSpPr>
-          <p:cNvPr id="10" name="Text 6"/>
-          <p:cNvSpPr/>
-          <p:nvPr/>
-        </p:nvSpPr>
-        <p:spPr>
-          <a:xfrm>
-            <a:off x="1325880" y="3264408"/>
-            <a:ext cx="4617720" cy="822960"/>
-          </a:xfrm>
-          <a:prstGeom prst="rect">
-            <a:avLst/>
-          </a:prstGeom>
-          <a:noFill/>
-          <a:ln/>
-        </p:spPr>
-        <p:txBody>
-          <a:bodyPr wrap="square" lIns="0" tIns="0" rIns="0" bIns="0" rtlCol="0" anchor="ctr"/>
-          <a:lstStyle/>
-          <a:p>
-            <a:pPr indent="0" marL="0">
-              <a:lnSpc>
-                <a:spcPct val="125000"/>
-              </a:lnSpc>
-              <a:buNone/>
-            </a:pPr>
-            <a:r>
-              <a:rPr lang="en-US" sz="1200" dirty="0">
-                <a:solidFill>
-                  <a:srgbClr val="5B6B79"/>
-                </a:solidFill>
-                <a:latin typeface="Calibri" pitchFamily="34" charset="0"/>
-                <a:ea typeface="Calibri" pitchFamily="34" charset="-122"/>
-                <a:cs typeface="Calibri" pitchFamily="34" charset="-120"/>
-              </a:rPr>
-              <a:t>Every route and every agent tool checks the same role gate.</a:t>
-            </a:r>
-            <a:endParaRPr lang="en-US" sz="1200" dirty="0"/>
-          </a:p>
-        </p:txBody>
-      </p:sp>
-      <p:sp>
-        <p:nvSpPr>
-          <p:cNvPr id="11" name="Shape 7"/>
-          <p:cNvSpPr/>
-          <p:nvPr/>
-        </p:nvSpPr>
-        <p:spPr>
-          <a:xfrm>
-            <a:off x="548640" y="4343400"/>
-            <a:ext cx="566928" cy="566928"/>
-          </a:xfrm>
-          <a:prstGeom prst="ellipse">
-            <a:avLst/>
-          </a:prstGeom>
-          <a:solidFill>
-            <a:srgbClr val="132A46"/>
-          </a:solidFill>
-          <a:ln/>
-        </p:spPr>
-      </p:sp>
-      <p:pic>
-        <p:nvPicPr>
-          <p:cNvPr id="12" name="Image 2" descr="preencoded.png">    </p:cNvPr>
-          <p:cNvPicPr>
-            <a:picLocks noChangeAspect="1"/>
-          </p:cNvPicPr>
-          <p:nvPr/>
-        </p:nvPicPr>
-        <p:blipFill>
-          <a:blip r:embed="rId3"/>
-          <a:stretch>
-            <a:fillRect/>
-          </a:stretch>
-        </p:blipFill>
-        <p:spPr>
-          <a:xfrm>
-            <a:off x="676199" y="4470959"/>
-            <a:ext cx="311810" cy="311810"/>
-          </a:xfrm>
-          <a:prstGeom prst="rect">
-            <a:avLst/>
-          </a:prstGeom>
-        </p:spPr>
-      </p:pic>
-      <p:sp>
-        <p:nvSpPr>
-          <p:cNvPr id="13" name="Text 8"/>
-          <p:cNvSpPr/>
-          <p:nvPr/>
-        </p:nvSpPr>
-        <p:spPr>
-          <a:xfrm>
-            <a:off x="1325880" y="4297680"/>
-            <a:ext cx="4617720" cy="365760"/>
-          </a:xfrm>
-          <a:prstGeom prst="rect">
-            <a:avLst/>
-          </a:prstGeom>
-          <a:noFill/>
-          <a:ln/>
-        </p:spPr>
-        <p:txBody>
-          <a:bodyPr wrap="square" lIns="0" tIns="0" rIns="0" bIns="0" rtlCol="0" anchor="ctr"/>
-          <a:lstStyle/>
-          <a:p>
-            <a:pPr indent="0" marL="0">
-              <a:buNone/>
-            </a:pPr>
-            <a:r>
-              <a:rPr lang="en-US" sz="1450" b="1" dirty="0">
-                <a:solidFill>
-                  <a:srgbClr val="132A46"/>
-                </a:solidFill>
-                <a:latin typeface="Calibri" pitchFamily="34" charset="0"/>
-                <a:ea typeface="Calibri" pitchFamily="34" charset="-122"/>
-                <a:cs typeface="Calibri" pitchFamily="34" charset="-120"/>
-              </a:rPr>
-              <a:t>Audit log on every AI call</a:t>
-            </a:r>
-            <a:endParaRPr lang="en-US" sz="1450" dirty="0"/>
-          </a:p>
-        </p:txBody>
-      </p:sp>
-      <p:sp>
-        <p:nvSpPr>
-          <p:cNvPr id="14" name="Text 9"/>
-          <p:cNvSpPr/>
-          <p:nvPr/>
-        </p:nvSpPr>
-        <p:spPr>
-          <a:xfrm>
-            <a:off x="1325880" y="4681728"/>
-            <a:ext cx="4617720" cy="822960"/>
-          </a:xfrm>
-          <a:prstGeom prst="rect">
-            <a:avLst/>
-          </a:prstGeom>
-          <a:noFill/>
-          <a:ln/>
-        </p:spPr>
-        <p:txBody>
-          <a:bodyPr wrap="square" lIns="0" tIns="0" rIns="0" bIns="0" rtlCol="0" anchor="ctr"/>
-          <a:lstStyle/>
-          <a:p>
-            <a:pPr indent="0" marL="0">
-              <a:lnSpc>
-                <a:spcPct val="125000"/>
-              </a:lnSpc>
-              <a:buNone/>
-            </a:pPr>
-            <a:r>
-              <a:rPr lang="en-US" sz="1200" dirty="0">
-                <a:solidFill>
-                  <a:srgbClr val="5B6B79"/>
-                </a:solidFill>
-                <a:latin typeface="Calibri" pitchFamily="34" charset="0"/>
-                <a:ea typeface="Calibri" pitchFamily="34" charset="-122"/>
-                <a:cs typeface="Calibri" pitchFamily="34" charset="-120"/>
-              </a:rPr>
-              <a:t>Who asked, what ran, and what it returned — always recorded.</a:t>
-            </a:r>
-            <a:endParaRPr lang="en-US" sz="1200" dirty="0"/>
-          </a:p>
-        </p:txBody>
-      </p:sp>
-      <p:sp>
-        <p:nvSpPr>
-          <p:cNvPr id="15" name="Shape 10"/>
-          <p:cNvSpPr/>
-          <p:nvPr/>
-        </p:nvSpPr>
-        <p:spPr>
-          <a:xfrm>
-            <a:off x="6446520" y="1508760"/>
-            <a:ext cx="566928" cy="566928"/>
-          </a:xfrm>
-          <a:prstGeom prst="ellipse">
-            <a:avLst/>
-          </a:prstGeom>
-          <a:solidFill>
-            <a:srgbClr val="E8622C"/>
-          </a:solidFill>
-          <a:ln/>
-        </p:spPr>
-      </p:sp>
-      <p:pic>
-        <p:nvPicPr>
-          <p:cNvPr id="16" name="Image 3" descr="preencoded.png">    </p:cNvPr>
-          <p:cNvPicPr>
-            <a:picLocks noChangeAspect="1"/>
-          </p:cNvPicPr>
-          <p:nvPr/>
-        </p:nvPicPr>
-        <p:blipFill>
-          <a:blip r:embed="rId4"/>
-          <a:stretch>
-            <a:fillRect/>
-          </a:stretch>
-        </p:blipFill>
-        <p:spPr>
-          <a:xfrm>
-            <a:off x="6574079" y="1636319"/>
-            <a:ext cx="311810" cy="311810"/>
-          </a:xfrm>
-          <a:prstGeom prst="rect">
-            <a:avLst/>
-          </a:prstGeom>
-        </p:spPr>
-      </p:pic>
-      <p:sp>
-        <p:nvSpPr>
-          <p:cNvPr id="17" name="Text 11"/>
-          <p:cNvSpPr/>
-          <p:nvPr/>
-        </p:nvSpPr>
-        <p:spPr>
-          <a:xfrm>
-            <a:off x="7223760" y="1463040"/>
-            <a:ext cx="4617720" cy="365760"/>
-          </a:xfrm>
-          <a:prstGeom prst="rect">
-            <a:avLst/>
-          </a:prstGeom>
-          <a:noFill/>
-          <a:ln/>
-        </p:spPr>
-        <p:txBody>
-          <a:bodyPr wrap="square" lIns="0" tIns="0" rIns="0" bIns="0" rtlCol="0" anchor="ctr"/>
-          <a:lstStyle/>
-          <a:p>
-            <a:pPr indent="0" marL="0">
-              <a:buNone/>
-            </a:pPr>
-            <a:r>
-              <a:rPr lang="en-US" sz="1450" b="1" dirty="0">
-                <a:solidFill>
-                  <a:srgbClr val="132A46"/>
-                </a:solidFill>
-                <a:latin typeface="Calibri" pitchFamily="34" charset="0"/>
-                <a:ea typeface="Calibri" pitchFamily="34" charset="-122"/>
-                <a:cs typeface="Calibri" pitchFamily="34" charset="-120"/>
-              </a:rPr>
-              <a:t>Human approval on risk</a:t>
-            </a:r>
-            <a:endParaRPr lang="en-US" sz="1450" dirty="0"/>
-          </a:p>
-        </p:txBody>
-      </p:sp>
-      <p:sp>
-        <p:nvSpPr>
-          <p:cNvPr id="18" name="Text 12"/>
-          <p:cNvSpPr/>
-          <p:nvPr/>
-        </p:nvSpPr>
-        <p:spPr>
-          <a:xfrm>
-            <a:off x="7223760" y="1847088"/>
-            <a:ext cx="4617720" cy="822960"/>
-          </a:xfrm>
-          <a:prstGeom prst="rect">
-            <a:avLst/>
-          </a:prstGeom>
-          <a:noFill/>
-          <a:ln/>
-        </p:spPr>
-        <p:txBody>
-          <a:bodyPr wrap="square" lIns="0" tIns="0" rIns="0" bIns="0" rtlCol="0" anchor="ctr"/>
-          <a:lstStyle/>
-          <a:p>
-            <a:pPr indent="0" marL="0">
-              <a:lnSpc>
-                <a:spcPct val="125000"/>
-              </a:lnSpc>
-              <a:buNone/>
-            </a:pPr>
-            <a:r>
-              <a:rPr lang="en-US" sz="1200" dirty="0">
-                <a:solidFill>
-                  <a:srgbClr val="5B6B79"/>
-                </a:solidFill>
-                <a:latin typeface="Calibri" pitchFamily="34" charset="0"/>
-                <a:ea typeface="Calibri" pitchFamily="34" charset="-122"/>
-                <a:cs typeface="Calibri" pitchFamily="34" charset="-120"/>
-              </a:rPr>
-              <a:t>High-risk actions become an approval request; the AI never executes alone.</a:t>
-            </a:r>
-            <a:endParaRPr lang="en-US" sz="1200" dirty="0"/>
-          </a:p>
-        </p:txBody>
-      </p:sp>
-      <p:sp>
-        <p:nvSpPr>
-          <p:cNvPr id="19" name="Shape 13"/>
-          <p:cNvSpPr/>
-          <p:nvPr/>
-        </p:nvSpPr>
-        <p:spPr>
-          <a:xfrm>
-            <a:off x="6446520" y="2926080"/>
-            <a:ext cx="566928" cy="566928"/>
-          </a:xfrm>
-          <a:prstGeom prst="ellipse">
-            <a:avLst/>
-          </a:prstGeom>
-          <a:solidFill>
-            <a:srgbClr val="E8622C"/>
-          </a:solidFill>
-          <a:ln/>
-        </p:spPr>
-      </p:sp>
-      <p:pic>
-        <p:nvPicPr>
-          <p:cNvPr id="20" name="Image 4" descr="preencoded.png">    </p:cNvPr>
-          <p:cNvPicPr>
-            <a:picLocks noChangeAspect="1"/>
-          </p:cNvPicPr>
-          <p:nvPr/>
-        </p:nvPicPr>
-        <p:blipFill>
-          <a:blip r:embed="rId5"/>
-          <a:stretch>
-            <a:fillRect/>
-          </a:stretch>
-        </p:blipFill>
-        <p:spPr>
-          <a:xfrm>
-            <a:off x="6574079" y="3053639"/>
-            <a:ext cx="311810" cy="311810"/>
-          </a:xfrm>
-          <a:prstGeom prst="rect">
-            <a:avLst/>
-          </a:prstGeom>
-        </p:spPr>
-      </p:pic>
-      <p:sp>
-        <p:nvSpPr>
-          <p:cNvPr id="21" name="Text 14"/>
-          <p:cNvSpPr/>
-          <p:nvPr/>
-        </p:nvSpPr>
-        <p:spPr>
-          <a:xfrm>
-            <a:off x="7223760" y="2880360"/>
-            <a:ext cx="4617720" cy="365760"/>
-          </a:xfrm>
-          <a:prstGeom prst="rect">
-            <a:avLst/>
-          </a:prstGeom>
-          <a:noFill/>
-          <a:ln/>
-        </p:spPr>
-        <p:txBody>
-          <a:bodyPr wrap="square" lIns="0" tIns="0" rIns="0" bIns="0" rtlCol="0" anchor="ctr"/>
-          <a:lstStyle/>
-          <a:p>
-            <a:pPr indent="0" marL="0">
-              <a:buNone/>
-            </a:pPr>
-            <a:r>
-              <a:rPr lang="en-US" sz="1450" b="1" dirty="0">
-                <a:solidFill>
-                  <a:srgbClr val="132A46"/>
-                </a:solidFill>
-                <a:latin typeface="Calibri" pitchFamily="34" charset="0"/>
-                <a:ea typeface="Calibri" pitchFamily="34" charset="-122"/>
-                <a:cs typeface="Calibri" pitchFamily="34" charset="-120"/>
-              </a:rPr>
-              <a:t>Approvals move work forward</a:t>
-            </a:r>
-            <a:endParaRPr lang="en-US" sz="1450" dirty="0"/>
-          </a:p>
-        </p:txBody>
-      </p:sp>
-      <p:sp>
-        <p:nvSpPr>
-          <p:cNvPr id="22" name="Text 15"/>
-          <p:cNvSpPr/>
-          <p:nvPr/>
-        </p:nvSpPr>
-        <p:spPr>
-          <a:xfrm>
-            <a:off x="7223760" y="3264408"/>
-            <a:ext cx="4617720" cy="822960"/>
-          </a:xfrm>
-          <a:prstGeom prst="rect">
-            <a:avLst/>
-          </a:prstGeom>
-          <a:noFill/>
-          <a:ln/>
-        </p:spPr>
-        <p:txBody>
-          <a:bodyPr wrap="square" lIns="0" tIns="0" rIns="0" bIns="0" rtlCol="0" anchor="ctr"/>
-          <a:lstStyle/>
-          <a:p>
-            <a:pPr indent="0" marL="0">
-              <a:lnSpc>
-                <a:spcPct val="125000"/>
-              </a:lnSpc>
-              <a:buNone/>
-            </a:pPr>
-            <a:r>
-              <a:rPr lang="en-US" sz="1200" dirty="0">
-                <a:solidFill>
-                  <a:srgbClr val="5B6B79"/>
-                </a:solidFill>
-                <a:latin typeface="Calibri" pitchFamily="34" charset="0"/>
-                <a:ea typeface="Calibri" pitchFamily="34" charset="-122"/>
-                <a:cs typeface="Calibri" pitchFamily="34" charset="-120"/>
-              </a:rPr>
-              <a:t>Approving a request changes the record it decided, not just a log entry.</a:t>
-            </a:r>
-            <a:endParaRPr lang="en-US" sz="1200" dirty="0"/>
-          </a:p>
-        </p:txBody>
-      </p:sp>
-      <p:sp>
-        <p:nvSpPr>
-          <p:cNvPr id="23" name="Shape 16"/>
-          <p:cNvSpPr/>
-          <p:nvPr/>
-        </p:nvSpPr>
-        <p:spPr>
-          <a:xfrm>
-            <a:off x="6446520" y="4343400"/>
-            <a:ext cx="566928" cy="566928"/>
-          </a:xfrm>
-          <a:prstGeom prst="ellipse">
-            <a:avLst/>
-          </a:prstGeom>
-          <a:solidFill>
-            <a:srgbClr val="E8622C"/>
-          </a:solidFill>
-          <a:ln/>
-        </p:spPr>
-      </p:sp>
-      <p:pic>
-        <p:nvPicPr>
-          <p:cNvPr id="24" name="Image 5" descr="preencoded.png">    </p:cNvPr>
-          <p:cNvPicPr>
-            <a:picLocks noChangeAspect="1"/>
-          </p:cNvPicPr>
-          <p:nvPr/>
-        </p:nvPicPr>
-        <p:blipFill>
-          <a:blip r:embed="rId6"/>
-          <a:stretch>
-            <a:fillRect/>
-          </a:stretch>
-        </p:blipFill>
-        <p:spPr>
-          <a:xfrm>
-            <a:off x="6574079" y="4470959"/>
-            <a:ext cx="311810" cy="311810"/>
-          </a:xfrm>
-          <a:prstGeom prst="rect">
-            <a:avLst/>
-          </a:prstGeom>
-        </p:spPr>
-      </p:pic>
-      <p:sp>
-        <p:nvSpPr>
-          <p:cNvPr id="25" name="Text 17"/>
-          <p:cNvSpPr/>
-          <p:nvPr/>
-        </p:nvSpPr>
-        <p:spPr>
-          <a:xfrm>
-            <a:off x="7223760" y="4297680"/>
-            <a:ext cx="4617720" cy="365760"/>
-          </a:xfrm>
-          <a:prstGeom prst="rect">
-            <a:avLst/>
-          </a:prstGeom>
-          <a:noFill/>
-          <a:ln/>
-        </p:spPr>
-        <p:txBody>
-          <a:bodyPr wrap="square" lIns="0" tIns="0" rIns="0" bIns="0" rtlCol="0" anchor="ctr"/>
-          <a:lstStyle/>
-          <a:p>
-            <a:pPr indent="0" marL="0">
-              <a:buNone/>
-            </a:pPr>
-            <a:r>
-              <a:rPr lang="en-US" sz="1450" b="1" dirty="0">
-                <a:solidFill>
-                  <a:srgbClr val="132A46"/>
-                </a:solidFill>
-                <a:latin typeface="Calibri" pitchFamily="34" charset="0"/>
-                <a:ea typeface="Calibri" pitchFamily="34" charset="-122"/>
-                <a:cs typeface="Calibri" pitchFamily="34" charset="-120"/>
-              </a:rPr>
-              <a:t>Concurrency-safe</a:t>
-            </a:r>
-            <a:endParaRPr lang="en-US" sz="1450" dirty="0"/>
-          </a:p>
-        </p:txBody>
-      </p:sp>
-      <p:sp>
-        <p:nvSpPr>
-          <p:cNvPr id="26" name="Text 18"/>
-          <p:cNvSpPr/>
-          <p:nvPr/>
-        </p:nvSpPr>
-        <p:spPr>
-          <a:xfrm>
-            <a:off x="7223760" y="4681728"/>
-            <a:ext cx="4617720" cy="822960"/>
-          </a:xfrm>
-          <a:prstGeom prst="rect">
-            <a:avLst/>
-          </a:prstGeom>
-          <a:noFill/>
-          <a:ln/>
-        </p:spPr>
-        <p:txBody>
-          <a:bodyPr wrap="square" lIns="0" tIns="0" rIns="0" bIns="0" rtlCol="0" anchor="ctr"/>
-          <a:lstStyle/>
-          <a:p>
-            <a:pPr indent="0" marL="0">
-              <a:lnSpc>
-                <a:spcPct val="125000"/>
-              </a:lnSpc>
-              <a:buNone/>
-            </a:pPr>
-            <a:r>
-              <a:rPr lang="en-US" sz="1200" dirty="0">
-                <a:solidFill>
-                  <a:srgbClr val="5B6B79"/>
-                </a:solidFill>
-                <a:latin typeface="Calibri" pitchFamily="34" charset="0"/>
-                <a:ea typeface="Calibri" pitchFamily="34" charset="-122"/>
-                <a:cs typeface="Calibri" pitchFamily="34" charset="-120"/>
-              </a:rPr>
-              <a:t>Two simultaneous approvals on one request — exactly one ever wins.</a:t>
-            </a:r>
-            <a:endParaRPr lang="en-US" sz="1200" dirty="0"/>
-          </a:p>
-        </p:txBody>
-      </p:sp>
-      <p:sp>
-        <p:nvSpPr>
-          <p:cNvPr id="27" name="Text 19"/>
           <p:cNvSpPr/>
           <p:nvPr/>
         </p:nvSpPr>
@@ -11818,7 +10121,7 @@
           <a:bodyPr wrap="square" lIns="0" tIns="0" rIns="0" bIns="0" rtlCol="0" anchor="ctr"/>
           <a:lstStyle/>
           <a:p>
-            <a:pPr algn="l" indent="0" marL="0">
+            <a:pPr indent="0" marL="0">
               <a:buNone/>
             </a:pPr>
             <a:r>
@@ -11838,7 +10141,7 @@
       </p:sp>
       <p:sp>
         <p:nvSpPr>
-          <p:cNvPr id="28" name="Text 20"/>
+          <p:cNvPr id="7" name="Text 4"/>
           <p:cNvSpPr/>
           <p:nvPr/>
         </p:nvSpPr>

</xml_diff>